<commit_message>
docs: seccion predictor en informe.md + slide 15 XGBoost en defensa (17 slides)
informe_resultados.md:
- Nueva seccion 9 'Modulo Predictor Temporal XGBoost' con tablas comparativa,
  features, umbrales, corridas P4-P10 y diagrama de arquitectura de integracion
- Referencias renumeradas a seccion 10

generar_slides_defensa.py / slides_defensa_PPI_UPeU_2026.pptx:
- Slide 15 nuevo: Predictor XGBoost con tabla corridas, KPIs TPR=100%/FPR=0%,
  comparacion ARIMA/RF/XGBoost y descripcion de la senal gap
- Agenda actualizada: 16 items (predictor como item 13)
- Total: 16 -> 17 slides
- Trabajo futuro: ensemble IF+AE y LSTM como proximos pasos

Co-Authored-By: Claude Sonnet 4.6 <noreply@anthropic.com>
</commit_message>
<xml_diff>
--- a/results/slides_defensa_PPI_UPeU_2026.pptx
+++ b/results/slides_defensa_PPI_UPeU_2026.pptx
@@ -21,6 +21,7 @@
     <p:sldId id="269" r:id="rId20"/>
     <p:sldId id="270" r:id="rId21"/>
     <p:sldId id="271" r:id="rId22"/>
+    <p:sldId id="272" r:id="rId23"/>
   </p:sldIdLst>
   <p:sldSz cx="12188952" cy="6858000" type="screen4x3"/>
   <p:notesSz cx="6858000" cy="9144000"/>
@@ -3749,7 +3750,7 @@
                   <a:srgbClr val="FFFFFF"/>
                 </a:solidFill>
               </a:rPr>
-              <a:t>PPI — UPeU 2026  |  Rubén Salazar Tocas  |  10/16</a:t>
+              <a:t>PPI — UPeU 2026  |  Rubén Salazar Tocas  |  10/17</a:t>
             </a:r>
           </a:p>
         </p:txBody>
@@ -6352,7 +6353,7 @@
                   <a:srgbClr val="FFFFFF"/>
                 </a:solidFill>
               </a:rPr>
-              <a:t>PPI — UPeU 2026  |  Rubén Salazar Tocas  |  11/16</a:t>
+              <a:t>PPI — UPeU 2026  |  Rubén Salazar Tocas  |  11/17</a:t>
             </a:r>
           </a:p>
         </p:txBody>
@@ -8425,7 +8426,7 @@
                   <a:srgbClr val="FFFFFF"/>
                 </a:solidFill>
               </a:rPr>
-              <a:t>PPI — UPeU 2026  |  Rubén Salazar Tocas  |  12/16</a:t>
+              <a:t>PPI — UPeU 2026  |  Rubén Salazar Tocas  |  12/17</a:t>
             </a:r>
           </a:p>
         </p:txBody>
@@ -11116,7 +11117,7 @@
                   <a:srgbClr val="FFFFFF"/>
                 </a:solidFill>
               </a:rPr>
-              <a:t>PPI — UPeU 2026  |  Rubén Salazar Tocas  |  13/16</a:t>
+              <a:t>PPI — UPeU 2026  |  Rubén Salazar Tocas  |  13/17</a:t>
             </a:r>
           </a:p>
         </p:txBody>
@@ -14551,7 +14552,7 @@
                   <a:srgbClr val="FFFFFF"/>
                 </a:solidFill>
               </a:rPr>
-              <a:t>PPI — UPeU 2026  |  Rubén Salazar Tocas  |  14/16</a:t>
+              <a:t>PPI — UPeU 2026  |  Rubén Salazar Tocas  |  14/17</a:t>
             </a:r>
           </a:p>
         </p:txBody>
@@ -16186,7 +16187,7 @@
                   <a:srgbClr val="FFFFFF"/>
                 </a:solidFill>
               </a:rPr>
-              <a:t>Conclusiones</a:t>
+              <a:t>Módulo Predictor Temporal — XGBoost</a:t>
             </a:r>
           </a:p>
         </p:txBody>
@@ -16220,7 +16221,7 @@
                   <a:srgbClr val="D6E4F5"/>
                 </a:solidFill>
               </a:rPr>
-              <a:t>Lo que se logró — impacto y contribución</a:t>
+              <a:t>Anticipación predictiva integrada al motor IF (proceso paralelo)</a:t>
             </a:r>
           </a:p>
         </p:txBody>
@@ -16297,7 +16298,7 @@
                   <a:srgbClr val="FFFFFF"/>
                 </a:solidFill>
               </a:rPr>
-              <a:t>PPI — UPeU 2026  |  Rubén Salazar Tocas  |  15/16</a:t>
+              <a:t>PPI — UPeU 2026  |  Rubén Salazar Tocas  |  15/17</a:t>
             </a:r>
           </a:p>
         </p:txBody>
@@ -16310,85 +16311,8 @@
         </p:nvSpPr>
         <p:spPr>
           <a:xfrm>
-            <a:off x="274320" y="1508760"/>
-            <a:ext cx="457200" cy="868680"/>
-          </a:xfrm>
-          <a:prstGeom prst="rect">
-            <a:avLst/>
-          </a:prstGeom>
-          <a:solidFill>
-            <a:srgbClr val="1A7C4A"/>
-          </a:solidFill>
-          <a:ln>
-            <a:noFill/>
-          </a:ln>
-        </p:spPr>
-        <p:style>
-          <a:lnRef idx="1">
-            <a:schemeClr val="accent1"/>
-          </a:lnRef>
-          <a:fillRef idx="3">
-            <a:schemeClr val="accent1"/>
-          </a:fillRef>
-          <a:effectRef idx="2">
-            <a:schemeClr val="accent1"/>
-          </a:effectRef>
-          <a:fontRef idx="minor">
-            <a:schemeClr val="lt1"/>
-          </a:fontRef>
-        </p:style>
-        <p:txBody>
-          <a:bodyPr rtlCol="0" anchor="ctr"/>
-          <a:lstStyle/>
-          <a:p>
-            <a:pPr algn="ctr"/>
-          </a:p>
-        </p:txBody>
-      </p:sp>
-      <p:sp>
-        <p:nvSpPr>
-          <p:cNvPr id="9" name="TextBox 8"/>
-          <p:cNvSpPr txBox="1"/>
-          <p:nvPr/>
-        </p:nvSpPr>
-        <p:spPr>
-          <a:xfrm>
-            <a:off x="274320" y="1673352"/>
-            <a:ext cx="457200" cy="548640"/>
-          </a:xfrm>
-          <a:prstGeom prst="rect">
-            <a:avLst/>
-          </a:prstGeom>
-          <a:noFill/>
-        </p:spPr>
-        <p:txBody>
-          <a:bodyPr wrap="square">
-            <a:spAutoFit/>
-          </a:bodyPr>
-          <a:lstStyle/>
-          <a:p>
-            <a:pPr algn="ctr"/>
-            <a:r>
-              <a:rPr sz="2000" b="1" i="0">
-                <a:solidFill>
-                  <a:srgbClr val="FFFFFF"/>
-                </a:solidFill>
-              </a:rPr>
-              <a:t>1</a:t>
-            </a:r>
-          </a:p>
-        </p:txBody>
-      </p:sp>
-      <p:sp>
-        <p:nvSpPr>
-          <p:cNvPr id="10" name="Rectangle 9"/>
-          <p:cNvSpPr/>
-          <p:nvPr/>
-        </p:nvSpPr>
-        <p:spPr>
-          <a:xfrm>
-            <a:off x="822960" y="1508760"/>
-            <a:ext cx="11091672" cy="868680"/>
+            <a:off x="274320" y="1417320"/>
+            <a:ext cx="5486400" cy="5166360"/>
           </a:xfrm>
           <a:prstGeom prst="rect">
             <a:avLst/>
@@ -16426,14 +16350,82 @@
       </p:sp>
       <p:sp>
         <p:nvSpPr>
+          <p:cNvPr id="9" name="TextBox 8"/>
+          <p:cNvSpPr txBox="1"/>
+          <p:nvPr/>
+        </p:nvSpPr>
+        <p:spPr>
+          <a:xfrm>
+            <a:off x="411480" y="1508760"/>
+            <a:ext cx="5212080" cy="347472"/>
+          </a:xfrm>
+          <a:prstGeom prst="rect">
+            <a:avLst/>
+          </a:prstGeom>
+          <a:noFill/>
+        </p:spPr>
+        <p:txBody>
+          <a:bodyPr wrap="square">
+            <a:spAutoFit/>
+          </a:bodyPr>
+          <a:lstStyle/>
+          <a:p>
+            <a:pPr algn="l"/>
+            <a:r>
+              <a:rPr sz="1200" b="1" i="0">
+                <a:solidFill>
+                  <a:srgbClr val="002D62"/>
+                </a:solidFill>
+              </a:rPr>
+              <a:t>Señal predictiva — gap entre estadísticas</a:t>
+            </a:r>
+          </a:p>
+        </p:txBody>
+      </p:sp>
+      <p:sp>
+        <p:nvSpPr>
+          <p:cNvPr id="10" name="TextBox 9"/>
+          <p:cNvSpPr txBox="1"/>
+          <p:nvPr/>
+        </p:nvSpPr>
+        <p:spPr>
+          <a:xfrm>
+            <a:off x="457200" y="1920240"/>
+            <a:ext cx="5120640" cy="393192"/>
+          </a:xfrm>
+          <a:prstGeom prst="rect">
+            <a:avLst/>
+          </a:prstGeom>
+          <a:noFill/>
+        </p:spPr>
+        <p:txBody>
+          <a:bodyPr wrap="square">
+            <a:spAutoFit/>
+          </a:bodyPr>
+          <a:lstStyle/>
+          <a:p>
+            <a:pPr algn="l"/>
+            <a:r>
+              <a:rPr sz="1200" b="0" i="0">
+                <a:solidFill>
+                  <a:srgbClr val="1A1A1A"/>
+                </a:solidFill>
+              </a:rPr>
+              <a:t>• Motor escribe stats cada 500 flows</a:t>
+            </a:r>
+          </a:p>
+        </p:txBody>
+      </p:sp>
+      <p:sp>
+        <p:nvSpPr>
           <p:cNvPr id="11" name="TextBox 10"/>
           <p:cNvSpPr txBox="1"/>
           <p:nvPr/>
         </p:nvSpPr>
         <p:spPr>
           <a:xfrm>
-            <a:off x="960120" y="1563624"/>
-            <a:ext cx="10789920" cy="320040"/>
+            <a:off x="457200" y="2267712"/>
+            <a:ext cx="5120640" cy="393192"/>
           </a:xfrm>
           <a:prstGeom prst="rect">
             <a:avLst/>
@@ -16448,26 +16440,162 @@
           <a:p>
             <a:pPr algn="l"/>
             <a:r>
+              <a:rPr sz="1200" b="0" i="0">
+                <a:solidFill>
+                  <a:srgbClr val="1A1A1A"/>
+                </a:solidFill>
+              </a:rPr>
+              <a:t>• Normal:  gap ~ 174s   (tráfico bajo)</a:t>
+            </a:r>
+          </a:p>
+        </p:txBody>
+      </p:sp>
+      <p:sp>
+        <p:nvSpPr>
+          <p:cNvPr id="12" name="TextBox 11"/>
+          <p:cNvSpPr txBox="1"/>
+          <p:nvPr/>
+        </p:nvSpPr>
+        <p:spPr>
+          <a:xfrm>
+            <a:off x="457200" y="2615184"/>
+            <a:ext cx="5120640" cy="393192"/>
+          </a:xfrm>
+          <a:prstGeom prst="rect">
+            <a:avLst/>
+          </a:prstGeom>
+          <a:noFill/>
+        </p:spPr>
+        <p:txBody>
+          <a:bodyPr wrap="square">
+            <a:spAutoFit/>
+          </a:bodyPr>
+          <a:lstStyle/>
+          <a:p>
+            <a:pPr algn="l"/>
+            <a:r>
+              <a:rPr sz="1200" b="0" i="0">
+                <a:solidFill>
+                  <a:srgbClr val="1A1A1A"/>
+                </a:solidFill>
+              </a:rPr>
+              <a:t>• Ataque:  gap ~  17s   (10× más rápido)</a:t>
+            </a:r>
+          </a:p>
+        </p:txBody>
+      </p:sp>
+      <p:sp>
+        <p:nvSpPr>
+          <p:cNvPr id="13" name="TextBox 12"/>
+          <p:cNvSpPr txBox="1"/>
+          <p:nvPr/>
+        </p:nvSpPr>
+        <p:spPr>
+          <a:xfrm>
+            <a:off x="457200" y="2962656"/>
+            <a:ext cx="5120640" cy="393192"/>
+          </a:xfrm>
+          <a:prstGeom prst="rect">
+            <a:avLst/>
+          </a:prstGeom>
+          <a:noFill/>
+        </p:spPr>
+        <p:txBody>
+          <a:bodyPr wrap="square">
+            <a:spAutoFit/>
+          </a:bodyPr>
+          <a:lstStyle/>
+          <a:p>
+            <a:pPr algn="l"/>
+            <a:r>
+              <a:rPr sz="1200" b="0" i="0">
+                <a:solidFill>
+                  <a:srgbClr val="1A1A1A"/>
+                </a:solidFill>
+              </a:rPr>
+              <a:t>• Predictor mide cuánto tarda la próxima stats</a:t>
+            </a:r>
+          </a:p>
+        </p:txBody>
+      </p:sp>
+      <p:sp>
+        <p:nvSpPr>
+          <p:cNvPr id="14" name="TextBox 13"/>
+          <p:cNvSpPr txBox="1"/>
+          <p:nvPr/>
+        </p:nvSpPr>
+        <p:spPr>
+          <a:xfrm>
+            <a:off x="457200" y="3310128"/>
+            <a:ext cx="5120640" cy="393192"/>
+          </a:xfrm>
+          <a:prstGeom prst="rect">
+            <a:avLst/>
+          </a:prstGeom>
+          <a:noFill/>
+        </p:spPr>
+        <p:txBody>
+          <a:bodyPr wrap="square">
+            <a:spAutoFit/>
+          </a:bodyPr>
+          <a:lstStyle/>
+          <a:p>
+            <a:pPr algn="l"/>
+            <a:r>
+              <a:rPr sz="1200" b="0" i="0">
+                <a:solidFill>
+                  <a:srgbClr val="1A1A1A"/>
+                </a:solidFill>
+              </a:rPr>
+              <a:t>• → detecta aceleración ANTES del BLOCK</a:t>
+            </a:r>
+          </a:p>
+        </p:txBody>
+      </p:sp>
+      <p:sp>
+        <p:nvSpPr>
+          <p:cNvPr id="15" name="TextBox 14"/>
+          <p:cNvSpPr txBox="1"/>
+          <p:nvPr/>
+        </p:nvSpPr>
+        <p:spPr>
+          <a:xfrm>
+            <a:off x="411480" y="3246120"/>
+            <a:ext cx="5212080" cy="347472"/>
+          </a:xfrm>
+          <a:prstGeom prst="rect">
+            <a:avLst/>
+          </a:prstGeom>
+          <a:noFill/>
+        </p:spPr>
+        <p:txBody>
+          <a:bodyPr wrap="square">
+            <a:spAutoFit/>
+          </a:bodyPr>
+          <a:lstStyle/>
+          <a:p>
+            <a:pPr algn="l"/>
+            <a:r>
               <a:rPr sz="1200" b="1" i="0">
                 <a:solidFill>
                   <a:srgbClr val="002D62"/>
                 </a:solidFill>
               </a:rPr>
-              <a:t>Sistema funcional end-to-end</a:t>
-            </a:r>
-          </a:p>
-        </p:txBody>
-      </p:sp>
-      <p:sp>
-        <p:nvSpPr>
-          <p:cNvPr id="12" name="TextBox 11"/>
-          <p:cNvSpPr txBox="1"/>
-          <p:nvPr/>
-        </p:nvSpPr>
-        <p:spPr>
-          <a:xfrm>
-            <a:off x="960120" y="1874520"/>
-            <a:ext cx="10789920" cy="438912"/>
+              <a:t>Modelo seleccionado — XGBoost (AUC=0.58)</a:t>
+            </a:r>
+          </a:p>
+        </p:txBody>
+      </p:sp>
+      <p:sp>
+        <p:nvSpPr>
+          <p:cNvPr id="16" name="TextBox 15"/>
+          <p:cNvSpPr txBox="1"/>
+          <p:nvPr/>
+        </p:nvSpPr>
+        <p:spPr>
+          <a:xfrm>
+            <a:off x="457200" y="3657600"/>
+            <a:ext cx="5120640" cy="393192"/>
           </a:xfrm>
           <a:prstGeom prst="rect">
             <a:avLst/>
@@ -16482,103 +16610,162 @@
           <a:p>
             <a:pPr algn="l"/>
             <a:r>
-              <a:rPr sz="1100" b="0" i="0">
+              <a:rPr sz="1200" b="0" i="0">
                 <a:solidFill>
                   <a:srgbClr val="1A1A1A"/>
                 </a:solidFill>
               </a:rPr>
-              <a:t>Se implementó y validó un pipeline completo: captura (Suricata) → preproceso → Isolation Forest → motor tiempo real → control inline (ipset). Todas las fases F1-F6 operativas en laboratorio real.</a:t>
-            </a:r>
-          </a:p>
-        </p:txBody>
-      </p:sp>
-      <p:sp>
-        <p:nvSpPr>
-          <p:cNvPr id="13" name="Rectangle 12"/>
+              <a:t>• ARIMA:        AUC=0.50  (descartado)</a:t>
+            </a:r>
+          </a:p>
+        </p:txBody>
+      </p:sp>
+      <p:sp>
+        <p:nvSpPr>
+          <p:cNvPr id="17" name="TextBox 16"/>
+          <p:cNvSpPr txBox="1"/>
+          <p:nvPr/>
+        </p:nvSpPr>
+        <p:spPr>
+          <a:xfrm>
+            <a:off x="457200" y="4005072"/>
+            <a:ext cx="5120640" cy="393192"/>
+          </a:xfrm>
+          <a:prstGeom prst="rect">
+            <a:avLst/>
+          </a:prstGeom>
+          <a:noFill/>
+        </p:spPr>
+        <p:txBody>
+          <a:bodyPr wrap="square">
+            <a:spAutoFit/>
+          </a:bodyPr>
+          <a:lstStyle/>
+          <a:p>
+            <a:pPr algn="l"/>
+            <a:r>
+              <a:rPr sz="1200" b="0" i="0">
+                <a:solidFill>
+                  <a:srgbClr val="1A1A1A"/>
+                </a:solidFill>
+              </a:rPr>
+              <a:t>• Random Forest: AUC=0.48  (descartado)</a:t>
+            </a:r>
+          </a:p>
+        </p:txBody>
+      </p:sp>
+      <p:sp>
+        <p:nvSpPr>
+          <p:cNvPr id="18" name="TextBox 17"/>
+          <p:cNvSpPr txBox="1"/>
+          <p:nvPr/>
+        </p:nvSpPr>
+        <p:spPr>
+          <a:xfrm>
+            <a:off x="457200" y="4352544"/>
+            <a:ext cx="5120640" cy="393192"/>
+          </a:xfrm>
+          <a:prstGeom prst="rect">
+            <a:avLst/>
+          </a:prstGeom>
+          <a:noFill/>
+        </p:spPr>
+        <p:txBody>
+          <a:bodyPr wrap="square">
+            <a:spAutoFit/>
+          </a:bodyPr>
+          <a:lstStyle/>
+          <a:p>
+            <a:pPr algn="l"/>
+            <a:r>
+              <a:rPr sz="1200" b="0" i="0">
+                <a:solidFill>
+                  <a:srgbClr val="1A1A1A"/>
+                </a:solidFill>
+              </a:rPr>
+              <a:t>• XGBoost:      AUC=0.58  ✓ ELEGIDO</a:t>
+            </a:r>
+          </a:p>
+        </p:txBody>
+      </p:sp>
+      <p:sp>
+        <p:nvSpPr>
+          <p:cNvPr id="19" name="TextBox 18"/>
+          <p:cNvSpPr txBox="1"/>
+          <p:nvPr/>
+        </p:nvSpPr>
+        <p:spPr>
+          <a:xfrm>
+            <a:off x="457200" y="4700016"/>
+            <a:ext cx="5120640" cy="393192"/>
+          </a:xfrm>
+          <a:prstGeom prst="rect">
+            <a:avLst/>
+          </a:prstGeom>
+          <a:noFill/>
+        </p:spPr>
+        <p:txBody>
+          <a:bodyPr wrap="square">
+            <a:spAutoFit/>
+          </a:bodyPr>
+          <a:lstStyle/>
+          <a:p>
+            <a:pPr algn="l"/>
+            <a:r>
+              <a:rPr sz="1200" b="0" i="0">
+                <a:solidFill>
+                  <a:srgbClr val="1A1A1A"/>
+                </a:solidFill>
+              </a:rPr>
+              <a:t>• scale_pos_weight compensa desbalance</a:t>
+            </a:r>
+          </a:p>
+        </p:txBody>
+      </p:sp>
+      <p:sp>
+        <p:nvSpPr>
+          <p:cNvPr id="20" name="TextBox 19"/>
+          <p:cNvSpPr txBox="1"/>
+          <p:nvPr/>
+        </p:nvSpPr>
+        <p:spPr>
+          <a:xfrm>
+            <a:off x="457200" y="5047488"/>
+            <a:ext cx="5120640" cy="393192"/>
+          </a:xfrm>
+          <a:prstGeom prst="rect">
+            <a:avLst/>
+          </a:prstGeom>
+          <a:noFill/>
+        </p:spPr>
+        <p:txBody>
+          <a:bodyPr wrap="square">
+            <a:spAutoFit/>
+          </a:bodyPr>
+          <a:lstStyle/>
+          <a:p>
+            <a:pPr algn="l"/>
+            <a:r>
+              <a:rPr sz="1200" b="0" i="0">
+                <a:solidFill>
+                  <a:srgbClr val="1A1A1A"/>
+                </a:solidFill>
+              </a:rPr>
+              <a:t>• P ≥ 0.70  →  ALERTA-PREDICTIVA (log + SSE)</a:t>
+            </a:r>
+          </a:p>
+        </p:txBody>
+      </p:sp>
+      <p:sp>
+        <p:nvSpPr>
+          <p:cNvPr id="21" name="Rectangle 20"/>
           <p:cNvSpPr/>
           <p:nvPr/>
         </p:nvSpPr>
         <p:spPr>
           <a:xfrm>
-            <a:off x="274320" y="2496312"/>
-            <a:ext cx="457200" cy="868680"/>
-          </a:xfrm>
-          <a:prstGeom prst="rect">
-            <a:avLst/>
-          </a:prstGeom>
-          <a:solidFill>
-            <a:srgbClr val="1A7C4A"/>
-          </a:solidFill>
-          <a:ln>
-            <a:noFill/>
-          </a:ln>
-        </p:spPr>
-        <p:style>
-          <a:lnRef idx="1">
-            <a:schemeClr val="accent1"/>
-          </a:lnRef>
-          <a:fillRef idx="3">
-            <a:schemeClr val="accent1"/>
-          </a:fillRef>
-          <a:effectRef idx="2">
-            <a:schemeClr val="accent1"/>
-          </a:effectRef>
-          <a:fontRef idx="minor">
-            <a:schemeClr val="lt1"/>
-          </a:fontRef>
-        </p:style>
-        <p:txBody>
-          <a:bodyPr rtlCol="0" anchor="ctr"/>
-          <a:lstStyle/>
-          <a:p>
-            <a:pPr algn="ctr"/>
-          </a:p>
-        </p:txBody>
-      </p:sp>
-      <p:sp>
-        <p:nvSpPr>
-          <p:cNvPr id="14" name="TextBox 13"/>
-          <p:cNvSpPr txBox="1"/>
-          <p:nvPr/>
-        </p:nvSpPr>
-        <p:spPr>
-          <a:xfrm>
-            <a:off x="274320" y="2660904"/>
-            <a:ext cx="457200" cy="548640"/>
-          </a:xfrm>
-          <a:prstGeom prst="rect">
-            <a:avLst/>
-          </a:prstGeom>
-          <a:noFill/>
-        </p:spPr>
-        <p:txBody>
-          <a:bodyPr wrap="square">
-            <a:spAutoFit/>
-          </a:bodyPr>
-          <a:lstStyle/>
-          <a:p>
-            <a:pPr algn="ctr"/>
-            <a:r>
-              <a:rPr sz="2000" b="1" i="0">
-                <a:solidFill>
-                  <a:srgbClr val="FFFFFF"/>
-                </a:solidFill>
-              </a:rPr>
-              <a:t>2</a:t>
-            </a:r>
-          </a:p>
-        </p:txBody>
-      </p:sp>
-      <p:sp>
-        <p:nvSpPr>
-          <p:cNvPr id="15" name="Rectangle 14"/>
-          <p:cNvSpPr/>
-          <p:nvPr/>
-        </p:nvSpPr>
-        <p:spPr>
-          <a:xfrm>
-            <a:off x="822960" y="2496312"/>
-            <a:ext cx="11091672" cy="868680"/>
+            <a:off x="5943600" y="1417320"/>
+            <a:ext cx="5943600" cy="3017520"/>
           </a:xfrm>
           <a:prstGeom prst="rect">
             <a:avLst/>
@@ -16616,14 +16803,14 @@
       </p:sp>
       <p:sp>
         <p:nvSpPr>
-          <p:cNvPr id="16" name="TextBox 15"/>
-          <p:cNvSpPr txBox="1"/>
-          <p:nvPr/>
-        </p:nvSpPr>
-        <p:spPr>
-          <a:xfrm>
-            <a:off x="960120" y="2551176"/>
-            <a:ext cx="10789920" cy="320040"/>
+          <p:cNvPr id="22" name="TextBox 21"/>
+          <p:cNvSpPr txBox="1"/>
+          <p:nvPr/>
+        </p:nvSpPr>
+        <p:spPr>
+          <a:xfrm>
+            <a:off x="6080760" y="1508760"/>
+            <a:ext cx="5669280" cy="347472"/>
           </a:xfrm>
           <a:prstGeom prst="rect">
             <a:avLst/>
@@ -16643,61 +16830,27 @@
                   <a:srgbClr val="002D62"/>
                 </a:solidFill>
               </a:rPr>
-              <a:t>Métricas de calidad superiores</a:t>
-            </a:r>
-          </a:p>
-        </p:txBody>
-      </p:sp>
-      <p:sp>
-        <p:nvSpPr>
-          <p:cNvPr id="17" name="TextBox 16"/>
-          <p:cNvSpPr txBox="1"/>
-          <p:nvPr/>
-        </p:nvSpPr>
-        <p:spPr>
-          <a:xfrm>
-            <a:off x="960120" y="2862072"/>
-            <a:ext cx="10789920" cy="438912"/>
-          </a:xfrm>
-          <a:prstGeom prst="rect">
-            <a:avLst/>
-          </a:prstGeom>
-          <a:noFill/>
-        </p:spPr>
-        <p:txBody>
-          <a:bodyPr wrap="square">
-            <a:spAutoFit/>
-          </a:bodyPr>
-          <a:lstStyle/>
-          <a:p>
-            <a:pPr algn="l"/>
-            <a:r>
-              <a:rPr sz="1100" b="0" i="0">
-                <a:solidFill>
-                  <a:srgbClr val="1A1A1A"/>
-                </a:solidFill>
-              </a:rPr>
-              <a:t>AUC-ROC = 0.8998 (req. ≥ 0.85), Precisión = 99.54%, Recall = 99.40%, F1 = 0.9947. El modelo detecta anomalías con alta confianza sobre 14 features de capa de red.</a:t>
-            </a:r>
-          </a:p>
-        </p:txBody>
-      </p:sp>
-      <p:sp>
-        <p:nvSpPr>
-          <p:cNvPr id="18" name="Rectangle 17"/>
+              <a:t>Corridas de validación (P4-P10)</a:t>
+            </a:r>
+          </a:p>
+        </p:txBody>
+      </p:sp>
+      <p:sp>
+        <p:nvSpPr>
+          <p:cNvPr id="23" name="Rectangle 22"/>
           <p:cNvSpPr/>
           <p:nvPr/>
         </p:nvSpPr>
         <p:spPr>
           <a:xfrm>
-            <a:off x="274320" y="3483864"/>
-            <a:ext cx="457200" cy="868680"/>
+            <a:off x="5989320" y="1920240"/>
+            <a:ext cx="1280160" cy="329184"/>
           </a:xfrm>
           <a:prstGeom prst="rect">
             <a:avLst/>
           </a:prstGeom>
           <a:solidFill>
-            <a:srgbClr val="1A7C4A"/>
+            <a:srgbClr val="002D62"/>
           </a:solidFill>
           <a:ln>
             <a:noFill/>
@@ -16727,48 +16880,595 @@
       </p:sp>
       <p:sp>
         <p:nvSpPr>
-          <p:cNvPr id="19" name="TextBox 18"/>
-          <p:cNvSpPr txBox="1"/>
-          <p:nvPr/>
-        </p:nvSpPr>
-        <p:spPr>
-          <a:xfrm>
-            <a:off x="274320" y="3648456"/>
-            <a:ext cx="457200" cy="548640"/>
-          </a:xfrm>
-          <a:prstGeom prst="rect">
-            <a:avLst/>
-          </a:prstGeom>
-          <a:noFill/>
-        </p:spPr>
-        <p:txBody>
-          <a:bodyPr wrap="square">
-            <a:spAutoFit/>
-          </a:bodyPr>
-          <a:lstStyle/>
-          <a:p>
-            <a:pPr algn="ctr"/>
-            <a:r>
-              <a:rPr sz="2000" b="1" i="0">
+          <p:cNvPr id="24" name="TextBox 23"/>
+          <p:cNvSpPr txBox="1"/>
+          <p:nvPr/>
+        </p:nvSpPr>
+        <p:spPr>
+          <a:xfrm>
+            <a:off x="6035040" y="1965960"/>
+            <a:ext cx="1188720" cy="329184"/>
+          </a:xfrm>
+          <a:prstGeom prst="rect">
+            <a:avLst/>
+          </a:prstGeom>
+          <a:noFill/>
+        </p:spPr>
+        <p:txBody>
+          <a:bodyPr wrap="square">
+            <a:spAutoFit/>
+          </a:bodyPr>
+          <a:lstStyle/>
+          <a:p>
+            <a:pPr algn="ctr"/>
+            <a:r>
+              <a:rPr sz="1100" b="1" i="0">
                 <a:solidFill>
                   <a:srgbClr val="FFFFFF"/>
                 </a:solidFill>
               </a:rPr>
-              <a:t>3</a:t>
-            </a:r>
-          </a:p>
-        </p:txBody>
-      </p:sp>
-      <p:sp>
-        <p:nvSpPr>
-          <p:cNvPr id="20" name="Rectangle 19"/>
+              <a:t>Corrida</a:t>
+            </a:r>
+          </a:p>
+        </p:txBody>
+      </p:sp>
+      <p:sp>
+        <p:nvSpPr>
+          <p:cNvPr id="25" name="Rectangle 24"/>
           <p:cNvSpPr/>
           <p:nvPr/>
         </p:nvSpPr>
         <p:spPr>
           <a:xfrm>
-            <a:off x="822960" y="3483864"/>
-            <a:ext cx="11091672" cy="868680"/>
+            <a:off x="7269480" y="1920240"/>
+            <a:ext cx="1280160" cy="329184"/>
+          </a:xfrm>
+          <a:prstGeom prst="rect">
+            <a:avLst/>
+          </a:prstGeom>
+          <a:solidFill>
+            <a:srgbClr val="002D62"/>
+          </a:solidFill>
+          <a:ln>
+            <a:noFill/>
+          </a:ln>
+        </p:spPr>
+        <p:style>
+          <a:lnRef idx="1">
+            <a:schemeClr val="accent1"/>
+          </a:lnRef>
+          <a:fillRef idx="3">
+            <a:schemeClr val="accent1"/>
+          </a:fillRef>
+          <a:effectRef idx="2">
+            <a:schemeClr val="accent1"/>
+          </a:effectRef>
+          <a:fontRef idx="minor">
+            <a:schemeClr val="lt1"/>
+          </a:fontRef>
+        </p:style>
+        <p:txBody>
+          <a:bodyPr rtlCol="0" anchor="ctr"/>
+          <a:lstStyle/>
+          <a:p>
+            <a:pPr algn="ctr"/>
+          </a:p>
+        </p:txBody>
+      </p:sp>
+      <p:sp>
+        <p:nvSpPr>
+          <p:cNvPr id="26" name="TextBox 25"/>
+          <p:cNvSpPr txBox="1"/>
+          <p:nvPr/>
+        </p:nvSpPr>
+        <p:spPr>
+          <a:xfrm>
+            <a:off x="7315200" y="1965960"/>
+            <a:ext cx="1188720" cy="329184"/>
+          </a:xfrm>
+          <a:prstGeom prst="rect">
+            <a:avLst/>
+          </a:prstGeom>
+          <a:noFill/>
+        </p:spPr>
+        <p:txBody>
+          <a:bodyPr wrap="square">
+            <a:spAutoFit/>
+          </a:bodyPr>
+          <a:lstStyle/>
+          <a:p>
+            <a:pPr algn="ctr"/>
+            <a:r>
+              <a:rPr sz="1100" b="1" i="0">
+                <a:solidFill>
+                  <a:srgbClr val="FFFFFF"/>
+                </a:solidFill>
+              </a:rPr>
+              <a:t>Tipo</a:t>
+            </a:r>
+          </a:p>
+        </p:txBody>
+      </p:sp>
+      <p:sp>
+        <p:nvSpPr>
+          <p:cNvPr id="27" name="Rectangle 26"/>
+          <p:cNvSpPr/>
+          <p:nvPr/>
+        </p:nvSpPr>
+        <p:spPr>
+          <a:xfrm>
+            <a:off x="8549640" y="1920240"/>
+            <a:ext cx="2011680" cy="329184"/>
+          </a:xfrm>
+          <a:prstGeom prst="rect">
+            <a:avLst/>
+          </a:prstGeom>
+          <a:solidFill>
+            <a:srgbClr val="002D62"/>
+          </a:solidFill>
+          <a:ln>
+            <a:noFill/>
+          </a:ln>
+        </p:spPr>
+        <p:style>
+          <a:lnRef idx="1">
+            <a:schemeClr val="accent1"/>
+          </a:lnRef>
+          <a:fillRef idx="3">
+            <a:schemeClr val="accent1"/>
+          </a:fillRef>
+          <a:effectRef idx="2">
+            <a:schemeClr val="accent1"/>
+          </a:effectRef>
+          <a:fontRef idx="minor">
+            <a:schemeClr val="lt1"/>
+          </a:fontRef>
+        </p:style>
+        <p:txBody>
+          <a:bodyPr rtlCol="0" anchor="ctr"/>
+          <a:lstStyle/>
+          <a:p>
+            <a:pPr algn="ctr"/>
+          </a:p>
+        </p:txBody>
+      </p:sp>
+      <p:sp>
+        <p:nvSpPr>
+          <p:cNvPr id="28" name="TextBox 27"/>
+          <p:cNvSpPr txBox="1"/>
+          <p:nvPr/>
+        </p:nvSpPr>
+        <p:spPr>
+          <a:xfrm>
+            <a:off x="8595360" y="1965960"/>
+            <a:ext cx="1920240" cy="329184"/>
+          </a:xfrm>
+          <a:prstGeom prst="rect">
+            <a:avLst/>
+          </a:prstGeom>
+          <a:noFill/>
+        </p:spPr>
+        <p:txBody>
+          <a:bodyPr wrap="square">
+            <a:spAutoFit/>
+          </a:bodyPr>
+          <a:lstStyle/>
+          <a:p>
+            <a:pPr algn="ctr"/>
+            <a:r>
+              <a:rPr sz="1100" b="1" i="0">
+                <a:solidFill>
+                  <a:srgbClr val="FFFFFF"/>
+                </a:solidFill>
+              </a:rPr>
+              <a:t>Resultado</a:t>
+            </a:r>
+          </a:p>
+        </p:txBody>
+      </p:sp>
+      <p:sp>
+        <p:nvSpPr>
+          <p:cNvPr id="29" name="Rectangle 28"/>
+          <p:cNvSpPr/>
+          <p:nvPr/>
+        </p:nvSpPr>
+        <p:spPr>
+          <a:xfrm>
+            <a:off x="10561320" y="1920240"/>
+            <a:ext cx="1097280" cy="329184"/>
+          </a:xfrm>
+          <a:prstGeom prst="rect">
+            <a:avLst/>
+          </a:prstGeom>
+          <a:solidFill>
+            <a:srgbClr val="002D62"/>
+          </a:solidFill>
+          <a:ln>
+            <a:noFill/>
+          </a:ln>
+        </p:spPr>
+        <p:style>
+          <a:lnRef idx="1">
+            <a:schemeClr val="accent1"/>
+          </a:lnRef>
+          <a:fillRef idx="3">
+            <a:schemeClr val="accent1"/>
+          </a:fillRef>
+          <a:effectRef idx="2">
+            <a:schemeClr val="accent1"/>
+          </a:effectRef>
+          <a:fontRef idx="minor">
+            <a:schemeClr val="lt1"/>
+          </a:fontRef>
+        </p:style>
+        <p:txBody>
+          <a:bodyPr rtlCol="0" anchor="ctr"/>
+          <a:lstStyle/>
+          <a:p>
+            <a:pPr algn="ctr"/>
+          </a:p>
+        </p:txBody>
+      </p:sp>
+      <p:sp>
+        <p:nvSpPr>
+          <p:cNvPr id="30" name="TextBox 29"/>
+          <p:cNvSpPr txBox="1"/>
+          <p:nvPr/>
+        </p:nvSpPr>
+        <p:spPr>
+          <a:xfrm>
+            <a:off x="10607040" y="1965960"/>
+            <a:ext cx="1005840" cy="329184"/>
+          </a:xfrm>
+          <a:prstGeom prst="rect">
+            <a:avLst/>
+          </a:prstGeom>
+          <a:noFill/>
+        </p:spPr>
+        <p:txBody>
+          <a:bodyPr wrap="square">
+            <a:spAutoFit/>
+          </a:bodyPr>
+          <a:lstStyle/>
+          <a:p>
+            <a:pPr algn="ctr"/>
+            <a:r>
+              <a:rPr sz="1100" b="1" i="0">
+                <a:solidFill>
+                  <a:srgbClr val="FFFFFF"/>
+                </a:solidFill>
+              </a:rPr>
+              <a:t>P%</a:t>
+            </a:r>
+          </a:p>
+        </p:txBody>
+      </p:sp>
+      <p:sp>
+        <p:nvSpPr>
+          <p:cNvPr id="31" name="Rectangle 30"/>
+          <p:cNvSpPr/>
+          <p:nvPr/>
+        </p:nvSpPr>
+        <p:spPr>
+          <a:xfrm>
+            <a:off x="5989320" y="2249424"/>
+            <a:ext cx="1280160" cy="329184"/>
+          </a:xfrm>
+          <a:prstGeom prst="rect">
+            <a:avLst/>
+          </a:prstGeom>
+          <a:solidFill>
+            <a:srgbClr val="D6E4F5"/>
+          </a:solidFill>
+          <a:ln w="12700">
+            <a:solidFill>
+              <a:srgbClr val="D6E4F5"/>
+            </a:solidFill>
+          </a:ln>
+        </p:spPr>
+        <p:style>
+          <a:lnRef idx="1">
+            <a:schemeClr val="accent1"/>
+          </a:lnRef>
+          <a:fillRef idx="3">
+            <a:schemeClr val="accent1"/>
+          </a:fillRef>
+          <a:effectRef idx="2">
+            <a:schemeClr val="accent1"/>
+          </a:effectRef>
+          <a:fontRef idx="minor">
+            <a:schemeClr val="lt1"/>
+          </a:fontRef>
+        </p:style>
+        <p:txBody>
+          <a:bodyPr rtlCol="0" anchor="ctr"/>
+          <a:lstStyle/>
+          <a:p>
+            <a:pPr algn="ctr"/>
+          </a:p>
+        </p:txBody>
+      </p:sp>
+      <p:sp>
+        <p:nvSpPr>
+          <p:cNvPr id="32" name="TextBox 31"/>
+          <p:cNvSpPr txBox="1"/>
+          <p:nvPr/>
+        </p:nvSpPr>
+        <p:spPr>
+          <a:xfrm>
+            <a:off x="6035040" y="2286000"/>
+            <a:ext cx="1188720" cy="329184"/>
+          </a:xfrm>
+          <a:prstGeom prst="rect">
+            <a:avLst/>
+          </a:prstGeom>
+          <a:noFill/>
+        </p:spPr>
+        <p:txBody>
+          <a:bodyPr wrap="square">
+            <a:spAutoFit/>
+          </a:bodyPr>
+          <a:lstStyle/>
+          <a:p>
+            <a:pPr algn="l"/>
+            <a:r>
+              <a:rPr sz="1100" b="0" i="0">
+                <a:solidFill>
+                  <a:srgbClr val="1A1A1A"/>
+                </a:solidFill>
+              </a:rPr>
+              <a:t>P4</a:t>
+            </a:r>
+          </a:p>
+        </p:txBody>
+      </p:sp>
+      <p:sp>
+        <p:nvSpPr>
+          <p:cNvPr id="33" name="Rectangle 32"/>
+          <p:cNvSpPr/>
+          <p:nvPr/>
+        </p:nvSpPr>
+        <p:spPr>
+          <a:xfrm>
+            <a:off x="7269480" y="2249424"/>
+            <a:ext cx="1280160" cy="329184"/>
+          </a:xfrm>
+          <a:prstGeom prst="rect">
+            <a:avLst/>
+          </a:prstGeom>
+          <a:solidFill>
+            <a:srgbClr val="D6E4F5"/>
+          </a:solidFill>
+          <a:ln w="12700">
+            <a:solidFill>
+              <a:srgbClr val="D6E4F5"/>
+            </a:solidFill>
+          </a:ln>
+        </p:spPr>
+        <p:style>
+          <a:lnRef idx="1">
+            <a:schemeClr val="accent1"/>
+          </a:lnRef>
+          <a:fillRef idx="3">
+            <a:schemeClr val="accent1"/>
+          </a:fillRef>
+          <a:effectRef idx="2">
+            <a:schemeClr val="accent1"/>
+          </a:effectRef>
+          <a:fontRef idx="minor">
+            <a:schemeClr val="lt1"/>
+          </a:fontRef>
+        </p:style>
+        <p:txBody>
+          <a:bodyPr rtlCol="0" anchor="ctr"/>
+          <a:lstStyle/>
+          <a:p>
+            <a:pPr algn="ctr"/>
+          </a:p>
+        </p:txBody>
+      </p:sp>
+      <p:sp>
+        <p:nvSpPr>
+          <p:cNvPr id="34" name="TextBox 33"/>
+          <p:cNvSpPr txBox="1"/>
+          <p:nvPr/>
+        </p:nvSpPr>
+        <p:spPr>
+          <a:xfrm>
+            <a:off x="7315200" y="2286000"/>
+            <a:ext cx="1188720" cy="329184"/>
+          </a:xfrm>
+          <a:prstGeom prst="rect">
+            <a:avLst/>
+          </a:prstGeom>
+          <a:noFill/>
+        </p:spPr>
+        <p:txBody>
+          <a:bodyPr wrap="square">
+            <a:spAutoFit/>
+          </a:bodyPr>
+          <a:lstStyle/>
+          <a:p>
+            <a:pPr algn="ctr"/>
+            <a:r>
+              <a:rPr sz="1100" b="0" i="0">
+                <a:solidFill>
+                  <a:srgbClr val="1A1A1A"/>
+                </a:solidFill>
+              </a:rPr>
+              <a:t>Ataque</a:t>
+            </a:r>
+          </a:p>
+        </p:txBody>
+      </p:sp>
+      <p:sp>
+        <p:nvSpPr>
+          <p:cNvPr id="35" name="Rectangle 34"/>
+          <p:cNvSpPr/>
+          <p:nvPr/>
+        </p:nvSpPr>
+        <p:spPr>
+          <a:xfrm>
+            <a:off x="8549640" y="2249424"/>
+            <a:ext cx="2011680" cy="329184"/>
+          </a:xfrm>
+          <a:prstGeom prst="rect">
+            <a:avLst/>
+          </a:prstGeom>
+          <a:solidFill>
+            <a:srgbClr val="D6E4F5"/>
+          </a:solidFill>
+          <a:ln w="12700">
+            <a:solidFill>
+              <a:srgbClr val="D6E4F5"/>
+            </a:solidFill>
+          </a:ln>
+        </p:spPr>
+        <p:style>
+          <a:lnRef idx="1">
+            <a:schemeClr val="accent1"/>
+          </a:lnRef>
+          <a:fillRef idx="3">
+            <a:schemeClr val="accent1"/>
+          </a:fillRef>
+          <a:effectRef idx="2">
+            <a:schemeClr val="accent1"/>
+          </a:effectRef>
+          <a:fontRef idx="minor">
+            <a:schemeClr val="lt1"/>
+          </a:fontRef>
+        </p:style>
+        <p:txBody>
+          <a:bodyPr rtlCol="0" anchor="ctr"/>
+          <a:lstStyle/>
+          <a:p>
+            <a:pPr algn="ctr"/>
+          </a:p>
+        </p:txBody>
+      </p:sp>
+      <p:sp>
+        <p:nvSpPr>
+          <p:cNvPr id="36" name="TextBox 35"/>
+          <p:cNvSpPr txBox="1"/>
+          <p:nvPr/>
+        </p:nvSpPr>
+        <p:spPr>
+          <a:xfrm>
+            <a:off x="8595360" y="2286000"/>
+            <a:ext cx="1920240" cy="329184"/>
+          </a:xfrm>
+          <a:prstGeom prst="rect">
+            <a:avLst/>
+          </a:prstGeom>
+          <a:noFill/>
+        </p:spPr>
+        <p:txBody>
+          <a:bodyPr wrap="square">
+            <a:spAutoFit/>
+          </a:bodyPr>
+          <a:lstStyle/>
+          <a:p>
+            <a:pPr algn="ctr"/>
+            <a:r>
+              <a:rPr sz="1100" b="0" i="0">
+                <a:solidFill>
+                  <a:srgbClr val="1A1A1A"/>
+                </a:solidFill>
+              </a:rPr>
+              <a:t>ALERTA ✓</a:t>
+            </a:r>
+          </a:p>
+        </p:txBody>
+      </p:sp>
+      <p:sp>
+        <p:nvSpPr>
+          <p:cNvPr id="37" name="Rectangle 36"/>
+          <p:cNvSpPr/>
+          <p:nvPr/>
+        </p:nvSpPr>
+        <p:spPr>
+          <a:xfrm>
+            <a:off x="10561320" y="2249424"/>
+            <a:ext cx="1097280" cy="329184"/>
+          </a:xfrm>
+          <a:prstGeom prst="rect">
+            <a:avLst/>
+          </a:prstGeom>
+          <a:solidFill>
+            <a:srgbClr val="D6E4F5"/>
+          </a:solidFill>
+          <a:ln w="12700">
+            <a:solidFill>
+              <a:srgbClr val="D6E4F5"/>
+            </a:solidFill>
+          </a:ln>
+        </p:spPr>
+        <p:style>
+          <a:lnRef idx="1">
+            <a:schemeClr val="accent1"/>
+          </a:lnRef>
+          <a:fillRef idx="3">
+            <a:schemeClr val="accent1"/>
+          </a:fillRef>
+          <a:effectRef idx="2">
+            <a:schemeClr val="accent1"/>
+          </a:effectRef>
+          <a:fontRef idx="minor">
+            <a:schemeClr val="lt1"/>
+          </a:fontRef>
+        </p:style>
+        <p:txBody>
+          <a:bodyPr rtlCol="0" anchor="ctr"/>
+          <a:lstStyle/>
+          <a:p>
+            <a:pPr algn="ctr"/>
+          </a:p>
+        </p:txBody>
+      </p:sp>
+      <p:sp>
+        <p:nvSpPr>
+          <p:cNvPr id="38" name="TextBox 37"/>
+          <p:cNvSpPr txBox="1"/>
+          <p:nvPr/>
+        </p:nvSpPr>
+        <p:spPr>
+          <a:xfrm>
+            <a:off x="10607040" y="2286000"/>
+            <a:ext cx="1005840" cy="329184"/>
+          </a:xfrm>
+          <a:prstGeom prst="rect">
+            <a:avLst/>
+          </a:prstGeom>
+          <a:noFill/>
+        </p:spPr>
+        <p:txBody>
+          <a:bodyPr wrap="square">
+            <a:spAutoFit/>
+          </a:bodyPr>
+          <a:lstStyle/>
+          <a:p>
+            <a:pPr algn="ctr"/>
+            <a:r>
+              <a:rPr sz="1100" b="0" i="0">
+                <a:solidFill>
+                  <a:srgbClr val="1A1A1A"/>
+                </a:solidFill>
+              </a:rPr>
+              <a:t>81.43%</a:t>
+            </a:r>
+          </a:p>
+        </p:txBody>
+      </p:sp>
+      <p:sp>
+        <p:nvSpPr>
+          <p:cNvPr id="39" name="Rectangle 38"/>
+          <p:cNvSpPr/>
+          <p:nvPr/>
+        </p:nvSpPr>
+        <p:spPr>
+          <a:xfrm>
+            <a:off x="5989320" y="2578608"/>
+            <a:ext cx="1280160" cy="329184"/>
           </a:xfrm>
           <a:prstGeom prst="rect">
             <a:avLst/>
@@ -16806,14 +17506,14 @@
       </p:sp>
       <p:sp>
         <p:nvSpPr>
-          <p:cNvPr id="21" name="TextBox 20"/>
-          <p:cNvSpPr txBox="1"/>
-          <p:nvPr/>
-        </p:nvSpPr>
-        <p:spPr>
-          <a:xfrm>
-            <a:off x="960120" y="3538728"/>
-            <a:ext cx="10789920" cy="320040"/>
+          <p:cNvPr id="40" name="TextBox 39"/>
+          <p:cNvSpPr txBox="1"/>
+          <p:nvPr/>
+        </p:nvSpPr>
+        <p:spPr>
+          <a:xfrm>
+            <a:off x="6035040" y="2615184"/>
+            <a:ext cx="1188720" cy="329184"/>
           </a:xfrm>
           <a:prstGeom prst="rect">
             <a:avLst/>
@@ -16828,137 +17528,26 @@
           <a:p>
             <a:pPr algn="l"/>
             <a:r>
-              <a:rPr sz="1200" b="1" i="0">
-                <a:solidFill>
-                  <a:srgbClr val="002D62"/>
-                </a:solidFill>
-              </a:rPr>
-              <a:t>Respuesta automática en tiempo real</a:t>
-            </a:r>
-          </a:p>
-        </p:txBody>
-      </p:sp>
-      <p:sp>
-        <p:nvSpPr>
-          <p:cNvPr id="22" name="TextBox 21"/>
-          <p:cNvSpPr txBox="1"/>
-          <p:nvPr/>
-        </p:nvSpPr>
-        <p:spPr>
-          <a:xfrm>
-            <a:off x="960120" y="3849624"/>
-            <a:ext cx="10789920" cy="438912"/>
-          </a:xfrm>
-          <a:prstGeom prst="rect">
-            <a:avLst/>
-          </a:prstGeom>
-          <a:noFill/>
-        </p:spPr>
-        <p:txBody>
-          <a:bodyPr wrap="square">
-            <a:spAutoFit/>
-          </a:bodyPr>
-          <a:lstStyle/>
-          <a:p>
-            <a:pPr algn="l"/>
-            <a:r>
               <a:rPr sz="1100" b="0" i="0">
                 <a:solidFill>
                   <a:srgbClr val="1A1A1A"/>
                 </a:solidFill>
               </a:rPr>
-              <a:t>Latencia P95 = 34.8ms (req. &lt;500ms, mejora de 14×). Lead Time de detección ≈ 62s limitado por el timeout de Suricata para flows TCP half-open.</a:t>
-            </a:r>
-          </a:p>
-        </p:txBody>
-      </p:sp>
-      <p:sp>
-        <p:nvSpPr>
-          <p:cNvPr id="23" name="Rectangle 22"/>
+              <a:t>P5</a:t>
+            </a:r>
+          </a:p>
+        </p:txBody>
+      </p:sp>
+      <p:sp>
+        <p:nvSpPr>
+          <p:cNvPr id="41" name="Rectangle 40"/>
           <p:cNvSpPr/>
           <p:nvPr/>
         </p:nvSpPr>
         <p:spPr>
           <a:xfrm>
-            <a:off x="274320" y="4471416"/>
-            <a:ext cx="457200" cy="868680"/>
-          </a:xfrm>
-          <a:prstGeom prst="rect">
-            <a:avLst/>
-          </a:prstGeom>
-          <a:solidFill>
-            <a:srgbClr val="1A7C4A"/>
-          </a:solidFill>
-          <a:ln>
-            <a:noFill/>
-          </a:ln>
-        </p:spPr>
-        <p:style>
-          <a:lnRef idx="1">
-            <a:schemeClr val="accent1"/>
-          </a:lnRef>
-          <a:fillRef idx="3">
-            <a:schemeClr val="accent1"/>
-          </a:fillRef>
-          <a:effectRef idx="2">
-            <a:schemeClr val="accent1"/>
-          </a:effectRef>
-          <a:fontRef idx="minor">
-            <a:schemeClr val="lt1"/>
-          </a:fontRef>
-        </p:style>
-        <p:txBody>
-          <a:bodyPr rtlCol="0" anchor="ctr"/>
-          <a:lstStyle/>
-          <a:p>
-            <a:pPr algn="ctr"/>
-          </a:p>
-        </p:txBody>
-      </p:sp>
-      <p:sp>
-        <p:nvSpPr>
-          <p:cNvPr id="24" name="TextBox 23"/>
-          <p:cNvSpPr txBox="1"/>
-          <p:nvPr/>
-        </p:nvSpPr>
-        <p:spPr>
-          <a:xfrm>
-            <a:off x="274320" y="4636008"/>
-            <a:ext cx="457200" cy="548640"/>
-          </a:xfrm>
-          <a:prstGeom prst="rect">
-            <a:avLst/>
-          </a:prstGeom>
-          <a:noFill/>
-        </p:spPr>
-        <p:txBody>
-          <a:bodyPr wrap="square">
-            <a:spAutoFit/>
-          </a:bodyPr>
-          <a:lstStyle/>
-          <a:p>
-            <a:pPr algn="ctr"/>
-            <a:r>
-              <a:rPr sz="2000" b="1" i="0">
-                <a:solidFill>
-                  <a:srgbClr val="FFFFFF"/>
-                </a:solidFill>
-              </a:rPr>
-              <a:t>4</a:t>
-            </a:r>
-          </a:p>
-        </p:txBody>
-      </p:sp>
-      <p:sp>
-        <p:nvSpPr>
-          <p:cNvPr id="25" name="Rectangle 24"/>
-          <p:cNvSpPr/>
-          <p:nvPr/>
-        </p:nvSpPr>
-        <p:spPr>
-          <a:xfrm>
-            <a:off x="822960" y="4471416"/>
-            <a:ext cx="11091672" cy="868680"/>
+            <a:off x="7269480" y="2578608"/>
+            <a:ext cx="1280160" cy="329184"/>
           </a:xfrm>
           <a:prstGeom prst="rect">
             <a:avLst/>
@@ -16996,159 +17585,48 @@
       </p:sp>
       <p:sp>
         <p:nvSpPr>
-          <p:cNvPr id="26" name="TextBox 25"/>
-          <p:cNvSpPr txBox="1"/>
-          <p:nvPr/>
-        </p:nvSpPr>
-        <p:spPr>
-          <a:xfrm>
-            <a:off x="960120" y="4526280"/>
-            <a:ext cx="10789920" cy="320040"/>
-          </a:xfrm>
-          <a:prstGeom prst="rect">
-            <a:avLst/>
-          </a:prstGeom>
-          <a:noFill/>
-        </p:spPr>
-        <p:txBody>
-          <a:bodyPr wrap="square">
-            <a:spAutoFit/>
-          </a:bodyPr>
-          <a:lstStyle/>
-          <a:p>
-            <a:pPr algn="l"/>
-            <a:r>
-              <a:rPr sz="1200" b="1" i="0">
-                <a:solidFill>
-                  <a:srgbClr val="002D62"/>
-                </a:solidFill>
-              </a:rPr>
-              <a:t>Disponibilidad garantizada</a:t>
-            </a:r>
-          </a:p>
-        </p:txBody>
-      </p:sp>
-      <p:sp>
-        <p:nvSpPr>
-          <p:cNvPr id="27" name="TextBox 26"/>
-          <p:cNvSpPr txBox="1"/>
-          <p:nvPr/>
-        </p:nvSpPr>
-        <p:spPr>
-          <a:xfrm>
-            <a:off x="960120" y="4837176"/>
-            <a:ext cx="10789920" cy="438912"/>
-          </a:xfrm>
-          <a:prstGeom prst="rect">
-            <a:avLst/>
-          </a:prstGeom>
-          <a:noFill/>
-        </p:spPr>
-        <p:txBody>
-          <a:bodyPr wrap="square">
-            <a:spAutoFit/>
-          </a:bodyPr>
-          <a:lstStyle/>
-          <a:p>
-            <a:pPr algn="l"/>
+          <p:cNvPr id="42" name="TextBox 41"/>
+          <p:cNvSpPr txBox="1"/>
+          <p:nvPr/>
+        </p:nvSpPr>
+        <p:spPr>
+          <a:xfrm>
+            <a:off x="7315200" y="2615184"/>
+            <a:ext cx="1188720" cy="329184"/>
+          </a:xfrm>
+          <a:prstGeom prst="rect">
+            <a:avLst/>
+          </a:prstGeom>
+          <a:noFill/>
+        </p:spPr>
+        <p:txBody>
+          <a:bodyPr wrap="square">
+            <a:spAutoFit/>
+          </a:bodyPr>
+          <a:lstStyle/>
+          <a:p>
+            <a:pPr algn="ctr"/>
             <a:r>
               <a:rPr sz="1100" b="0" i="0">
                 <a:solidFill>
                   <a:srgbClr val="1A1A1A"/>
                 </a:solidFill>
               </a:rPr>
-              <a:t>40/40 corridas con Disponibilidad = 100% e ITL = 0%. El mecanismo de whitelist previene auto-bloqueo del sistema.</a:t>
-            </a:r>
-          </a:p>
-        </p:txBody>
-      </p:sp>
-      <p:sp>
-        <p:nvSpPr>
-          <p:cNvPr id="28" name="Rectangle 27"/>
+              <a:t>Ataque</a:t>
+            </a:r>
+          </a:p>
+        </p:txBody>
+      </p:sp>
+      <p:sp>
+        <p:nvSpPr>
+          <p:cNvPr id="43" name="Rectangle 42"/>
           <p:cNvSpPr/>
           <p:nvPr/>
         </p:nvSpPr>
         <p:spPr>
           <a:xfrm>
-            <a:off x="274320" y="5458968"/>
-            <a:ext cx="457200" cy="868680"/>
-          </a:xfrm>
-          <a:prstGeom prst="rect">
-            <a:avLst/>
-          </a:prstGeom>
-          <a:solidFill>
-            <a:srgbClr val="1A7C4A"/>
-          </a:solidFill>
-          <a:ln>
-            <a:noFill/>
-          </a:ln>
-        </p:spPr>
-        <p:style>
-          <a:lnRef idx="1">
-            <a:schemeClr val="accent1"/>
-          </a:lnRef>
-          <a:fillRef idx="3">
-            <a:schemeClr val="accent1"/>
-          </a:fillRef>
-          <a:effectRef idx="2">
-            <a:schemeClr val="accent1"/>
-          </a:effectRef>
-          <a:fontRef idx="minor">
-            <a:schemeClr val="lt1"/>
-          </a:fontRef>
-        </p:style>
-        <p:txBody>
-          <a:bodyPr rtlCol="0" anchor="ctr"/>
-          <a:lstStyle/>
-          <a:p>
-            <a:pPr algn="ctr"/>
-          </a:p>
-        </p:txBody>
-      </p:sp>
-      <p:sp>
-        <p:nvSpPr>
-          <p:cNvPr id="29" name="TextBox 28"/>
-          <p:cNvSpPr txBox="1"/>
-          <p:nvPr/>
-        </p:nvSpPr>
-        <p:spPr>
-          <a:xfrm>
-            <a:off x="274320" y="5623560"/>
-            <a:ext cx="457200" cy="548640"/>
-          </a:xfrm>
-          <a:prstGeom prst="rect">
-            <a:avLst/>
-          </a:prstGeom>
-          <a:noFill/>
-        </p:spPr>
-        <p:txBody>
-          <a:bodyPr wrap="square">
-            <a:spAutoFit/>
-          </a:bodyPr>
-          <a:lstStyle/>
-          <a:p>
-            <a:pPr algn="ctr"/>
-            <a:r>
-              <a:rPr sz="2000" b="1" i="0">
-                <a:solidFill>
-                  <a:srgbClr val="FFFFFF"/>
-                </a:solidFill>
-              </a:rPr>
-              <a:t>5</a:t>
-            </a:r>
-          </a:p>
-        </p:txBody>
-      </p:sp>
-      <p:sp>
-        <p:nvSpPr>
-          <p:cNvPr id="30" name="Rectangle 29"/>
-          <p:cNvSpPr/>
-          <p:nvPr/>
-        </p:nvSpPr>
-        <p:spPr>
-          <a:xfrm>
-            <a:off x="822960" y="5458968"/>
-            <a:ext cx="11091672" cy="868680"/>
+            <a:off x="8549640" y="2578608"/>
+            <a:ext cx="2011680" cy="329184"/>
           </a:xfrm>
           <a:prstGeom prst="rect">
             <a:avLst/>
@@ -17186,14 +17664,172 @@
       </p:sp>
       <p:sp>
         <p:nvSpPr>
-          <p:cNvPr id="31" name="TextBox 30"/>
-          <p:cNvSpPr txBox="1"/>
-          <p:nvPr/>
-        </p:nvSpPr>
-        <p:spPr>
-          <a:xfrm>
-            <a:off x="960120" y="5513832"/>
-            <a:ext cx="10789920" cy="320040"/>
+          <p:cNvPr id="44" name="TextBox 43"/>
+          <p:cNvSpPr txBox="1"/>
+          <p:nvPr/>
+        </p:nvSpPr>
+        <p:spPr>
+          <a:xfrm>
+            <a:off x="8595360" y="2615184"/>
+            <a:ext cx="1920240" cy="329184"/>
+          </a:xfrm>
+          <a:prstGeom prst="rect">
+            <a:avLst/>
+          </a:prstGeom>
+          <a:noFill/>
+        </p:spPr>
+        <p:txBody>
+          <a:bodyPr wrap="square">
+            <a:spAutoFit/>
+          </a:bodyPr>
+          <a:lstStyle/>
+          <a:p>
+            <a:pPr algn="ctr"/>
+            <a:r>
+              <a:rPr sz="1100" b="0" i="0">
+                <a:solidFill>
+                  <a:srgbClr val="1A1A1A"/>
+                </a:solidFill>
+              </a:rPr>
+              <a:t>ALERTA ✓</a:t>
+            </a:r>
+          </a:p>
+        </p:txBody>
+      </p:sp>
+      <p:sp>
+        <p:nvSpPr>
+          <p:cNvPr id="45" name="Rectangle 44"/>
+          <p:cNvSpPr/>
+          <p:nvPr/>
+        </p:nvSpPr>
+        <p:spPr>
+          <a:xfrm>
+            <a:off x="10561320" y="2578608"/>
+            <a:ext cx="1097280" cy="329184"/>
+          </a:xfrm>
+          <a:prstGeom prst="rect">
+            <a:avLst/>
+          </a:prstGeom>
+          <a:solidFill>
+            <a:srgbClr val="FFFFFF"/>
+          </a:solidFill>
+          <a:ln w="12700">
+            <a:solidFill>
+              <a:srgbClr val="D6E4F5"/>
+            </a:solidFill>
+          </a:ln>
+        </p:spPr>
+        <p:style>
+          <a:lnRef idx="1">
+            <a:schemeClr val="accent1"/>
+          </a:lnRef>
+          <a:fillRef idx="3">
+            <a:schemeClr val="accent1"/>
+          </a:fillRef>
+          <a:effectRef idx="2">
+            <a:schemeClr val="accent1"/>
+          </a:effectRef>
+          <a:fontRef idx="minor">
+            <a:schemeClr val="lt1"/>
+          </a:fontRef>
+        </p:style>
+        <p:txBody>
+          <a:bodyPr rtlCol="0" anchor="ctr"/>
+          <a:lstStyle/>
+          <a:p>
+            <a:pPr algn="ctr"/>
+          </a:p>
+        </p:txBody>
+      </p:sp>
+      <p:sp>
+        <p:nvSpPr>
+          <p:cNvPr id="46" name="TextBox 45"/>
+          <p:cNvSpPr txBox="1"/>
+          <p:nvPr/>
+        </p:nvSpPr>
+        <p:spPr>
+          <a:xfrm>
+            <a:off x="10607040" y="2615184"/>
+            <a:ext cx="1005840" cy="329184"/>
+          </a:xfrm>
+          <a:prstGeom prst="rect">
+            <a:avLst/>
+          </a:prstGeom>
+          <a:noFill/>
+        </p:spPr>
+        <p:txBody>
+          <a:bodyPr wrap="square">
+            <a:spAutoFit/>
+          </a:bodyPr>
+          <a:lstStyle/>
+          <a:p>
+            <a:pPr algn="ctr"/>
+            <a:r>
+              <a:rPr sz="1100" b="0" i="0">
+                <a:solidFill>
+                  <a:srgbClr val="1A1A1A"/>
+                </a:solidFill>
+              </a:rPr>
+              <a:t>83.46%</a:t>
+            </a:r>
+          </a:p>
+        </p:txBody>
+      </p:sp>
+      <p:sp>
+        <p:nvSpPr>
+          <p:cNvPr id="47" name="Rectangle 46"/>
+          <p:cNvSpPr/>
+          <p:nvPr/>
+        </p:nvSpPr>
+        <p:spPr>
+          <a:xfrm>
+            <a:off x="5989320" y="2907792"/>
+            <a:ext cx="1280160" cy="329184"/>
+          </a:xfrm>
+          <a:prstGeom prst="rect">
+            <a:avLst/>
+          </a:prstGeom>
+          <a:solidFill>
+            <a:srgbClr val="D6E4F5"/>
+          </a:solidFill>
+          <a:ln w="12700">
+            <a:solidFill>
+              <a:srgbClr val="D6E4F5"/>
+            </a:solidFill>
+          </a:ln>
+        </p:spPr>
+        <p:style>
+          <a:lnRef idx="1">
+            <a:schemeClr val="accent1"/>
+          </a:lnRef>
+          <a:fillRef idx="3">
+            <a:schemeClr val="accent1"/>
+          </a:fillRef>
+          <a:effectRef idx="2">
+            <a:schemeClr val="accent1"/>
+          </a:effectRef>
+          <a:fontRef idx="minor">
+            <a:schemeClr val="lt1"/>
+          </a:fontRef>
+        </p:style>
+        <p:txBody>
+          <a:bodyPr rtlCol="0" anchor="ctr"/>
+          <a:lstStyle/>
+          <a:p>
+            <a:pPr algn="ctr"/>
+          </a:p>
+        </p:txBody>
+      </p:sp>
+      <p:sp>
+        <p:nvSpPr>
+          <p:cNvPr id="48" name="TextBox 47"/>
+          <p:cNvSpPr txBox="1"/>
+          <p:nvPr/>
+        </p:nvSpPr>
+        <p:spPr>
+          <a:xfrm>
+            <a:off x="6035040" y="2944368"/>
+            <a:ext cx="1188720" cy="329184"/>
           </a:xfrm>
           <a:prstGeom prst="rect">
             <a:avLst/>
@@ -17208,26 +17844,972 @@
           <a:p>
             <a:pPr algn="l"/>
             <a:r>
+              <a:rPr sz="1100" b="0" i="0">
+                <a:solidFill>
+                  <a:srgbClr val="1A1A1A"/>
+                </a:solidFill>
+              </a:rPr>
+              <a:t>P7</a:t>
+            </a:r>
+          </a:p>
+        </p:txBody>
+      </p:sp>
+      <p:sp>
+        <p:nvSpPr>
+          <p:cNvPr id="49" name="Rectangle 48"/>
+          <p:cNvSpPr/>
+          <p:nvPr/>
+        </p:nvSpPr>
+        <p:spPr>
+          <a:xfrm>
+            <a:off x="7269480" y="2907792"/>
+            <a:ext cx="1280160" cy="329184"/>
+          </a:xfrm>
+          <a:prstGeom prst="rect">
+            <a:avLst/>
+          </a:prstGeom>
+          <a:solidFill>
+            <a:srgbClr val="D6E4F5"/>
+          </a:solidFill>
+          <a:ln w="12700">
+            <a:solidFill>
+              <a:srgbClr val="D6E4F5"/>
+            </a:solidFill>
+          </a:ln>
+        </p:spPr>
+        <p:style>
+          <a:lnRef idx="1">
+            <a:schemeClr val="accent1"/>
+          </a:lnRef>
+          <a:fillRef idx="3">
+            <a:schemeClr val="accent1"/>
+          </a:fillRef>
+          <a:effectRef idx="2">
+            <a:schemeClr val="accent1"/>
+          </a:effectRef>
+          <a:fontRef idx="minor">
+            <a:schemeClr val="lt1"/>
+          </a:fontRef>
+        </p:style>
+        <p:txBody>
+          <a:bodyPr rtlCol="0" anchor="ctr"/>
+          <a:lstStyle/>
+          <a:p>
+            <a:pPr algn="ctr"/>
+          </a:p>
+        </p:txBody>
+      </p:sp>
+      <p:sp>
+        <p:nvSpPr>
+          <p:cNvPr id="50" name="TextBox 49"/>
+          <p:cNvSpPr txBox="1"/>
+          <p:nvPr/>
+        </p:nvSpPr>
+        <p:spPr>
+          <a:xfrm>
+            <a:off x="7315200" y="2944368"/>
+            <a:ext cx="1188720" cy="329184"/>
+          </a:xfrm>
+          <a:prstGeom prst="rect">
+            <a:avLst/>
+          </a:prstGeom>
+          <a:noFill/>
+        </p:spPr>
+        <p:txBody>
+          <a:bodyPr wrap="square">
+            <a:spAutoFit/>
+          </a:bodyPr>
+          <a:lstStyle/>
+          <a:p>
+            <a:pPr algn="ctr"/>
+            <a:r>
+              <a:rPr sz="1100" b="0" i="0">
+                <a:solidFill>
+                  <a:srgbClr val="1A1A1A"/>
+                </a:solidFill>
+              </a:rPr>
+              <a:t>Normal</a:t>
+            </a:r>
+          </a:p>
+        </p:txBody>
+      </p:sp>
+      <p:sp>
+        <p:nvSpPr>
+          <p:cNvPr id="51" name="Rectangle 50"/>
+          <p:cNvSpPr/>
+          <p:nvPr/>
+        </p:nvSpPr>
+        <p:spPr>
+          <a:xfrm>
+            <a:off x="8549640" y="2907792"/>
+            <a:ext cx="2011680" cy="329184"/>
+          </a:xfrm>
+          <a:prstGeom prst="rect">
+            <a:avLst/>
+          </a:prstGeom>
+          <a:solidFill>
+            <a:srgbClr val="D6E4F5"/>
+          </a:solidFill>
+          <a:ln w="12700">
+            <a:solidFill>
+              <a:srgbClr val="D6E4F5"/>
+            </a:solidFill>
+          </a:ln>
+        </p:spPr>
+        <p:style>
+          <a:lnRef idx="1">
+            <a:schemeClr val="accent1"/>
+          </a:lnRef>
+          <a:fillRef idx="3">
+            <a:schemeClr val="accent1"/>
+          </a:fillRef>
+          <a:effectRef idx="2">
+            <a:schemeClr val="accent1"/>
+          </a:effectRef>
+          <a:fontRef idx="minor">
+            <a:schemeClr val="lt1"/>
+          </a:fontRef>
+        </p:style>
+        <p:txBody>
+          <a:bodyPr rtlCol="0" anchor="ctr"/>
+          <a:lstStyle/>
+          <a:p>
+            <a:pPr algn="ctr"/>
+          </a:p>
+        </p:txBody>
+      </p:sp>
+      <p:sp>
+        <p:nvSpPr>
+          <p:cNvPr id="52" name="TextBox 51"/>
+          <p:cNvSpPr txBox="1"/>
+          <p:nvPr/>
+        </p:nvSpPr>
+        <p:spPr>
+          <a:xfrm>
+            <a:off x="8595360" y="2944368"/>
+            <a:ext cx="1920240" cy="329184"/>
+          </a:xfrm>
+          <a:prstGeom prst="rect">
+            <a:avLst/>
+          </a:prstGeom>
+          <a:noFill/>
+        </p:spPr>
+        <p:txBody>
+          <a:bodyPr wrap="square">
+            <a:spAutoFit/>
+          </a:bodyPr>
+          <a:lstStyle/>
+          <a:p>
+            <a:pPr algn="ctr"/>
+            <a:r>
+              <a:rPr sz="1100" b="0" i="0">
+                <a:solidFill>
+                  <a:srgbClr val="1A1A1A"/>
+                </a:solidFill>
+              </a:rPr>
+              <a:t>Sin alerta ✓</a:t>
+            </a:r>
+          </a:p>
+        </p:txBody>
+      </p:sp>
+      <p:sp>
+        <p:nvSpPr>
+          <p:cNvPr id="53" name="Rectangle 52"/>
+          <p:cNvSpPr/>
+          <p:nvPr/>
+        </p:nvSpPr>
+        <p:spPr>
+          <a:xfrm>
+            <a:off x="10561320" y="2907792"/>
+            <a:ext cx="1097280" cy="329184"/>
+          </a:xfrm>
+          <a:prstGeom prst="rect">
+            <a:avLst/>
+          </a:prstGeom>
+          <a:solidFill>
+            <a:srgbClr val="D6E4F5"/>
+          </a:solidFill>
+          <a:ln w="12700">
+            <a:solidFill>
+              <a:srgbClr val="D6E4F5"/>
+            </a:solidFill>
+          </a:ln>
+        </p:spPr>
+        <p:style>
+          <a:lnRef idx="1">
+            <a:schemeClr val="accent1"/>
+          </a:lnRef>
+          <a:fillRef idx="3">
+            <a:schemeClr val="accent1"/>
+          </a:fillRef>
+          <a:effectRef idx="2">
+            <a:schemeClr val="accent1"/>
+          </a:effectRef>
+          <a:fontRef idx="minor">
+            <a:schemeClr val="lt1"/>
+          </a:fontRef>
+        </p:style>
+        <p:txBody>
+          <a:bodyPr rtlCol="0" anchor="ctr"/>
+          <a:lstStyle/>
+          <a:p>
+            <a:pPr algn="ctr"/>
+          </a:p>
+        </p:txBody>
+      </p:sp>
+      <p:sp>
+        <p:nvSpPr>
+          <p:cNvPr id="54" name="TextBox 53"/>
+          <p:cNvSpPr txBox="1"/>
+          <p:nvPr/>
+        </p:nvSpPr>
+        <p:spPr>
+          <a:xfrm>
+            <a:off x="10607040" y="2944368"/>
+            <a:ext cx="1005840" cy="329184"/>
+          </a:xfrm>
+          <a:prstGeom prst="rect">
+            <a:avLst/>
+          </a:prstGeom>
+          <a:noFill/>
+        </p:spPr>
+        <p:txBody>
+          <a:bodyPr wrap="square">
+            <a:spAutoFit/>
+          </a:bodyPr>
+          <a:lstStyle/>
+          <a:p>
+            <a:pPr algn="ctr"/>
+            <a:r>
+              <a:rPr sz="1100" b="0" i="0">
+                <a:solidFill>
+                  <a:srgbClr val="1A1A1A"/>
+                </a:solidFill>
+              </a:rPr>
+              <a:t>—</a:t>
+            </a:r>
+          </a:p>
+        </p:txBody>
+      </p:sp>
+      <p:sp>
+        <p:nvSpPr>
+          <p:cNvPr id="55" name="Rectangle 54"/>
+          <p:cNvSpPr/>
+          <p:nvPr/>
+        </p:nvSpPr>
+        <p:spPr>
+          <a:xfrm>
+            <a:off x="5989320" y="3236976"/>
+            <a:ext cx="1280160" cy="329184"/>
+          </a:xfrm>
+          <a:prstGeom prst="rect">
+            <a:avLst/>
+          </a:prstGeom>
+          <a:solidFill>
+            <a:srgbClr val="FFFFFF"/>
+          </a:solidFill>
+          <a:ln w="12700">
+            <a:solidFill>
+              <a:srgbClr val="D6E4F5"/>
+            </a:solidFill>
+          </a:ln>
+        </p:spPr>
+        <p:style>
+          <a:lnRef idx="1">
+            <a:schemeClr val="accent1"/>
+          </a:lnRef>
+          <a:fillRef idx="3">
+            <a:schemeClr val="accent1"/>
+          </a:fillRef>
+          <a:effectRef idx="2">
+            <a:schemeClr val="accent1"/>
+          </a:effectRef>
+          <a:fontRef idx="minor">
+            <a:schemeClr val="lt1"/>
+          </a:fontRef>
+        </p:style>
+        <p:txBody>
+          <a:bodyPr rtlCol="0" anchor="ctr"/>
+          <a:lstStyle/>
+          <a:p>
+            <a:pPr algn="ctr"/>
+          </a:p>
+        </p:txBody>
+      </p:sp>
+      <p:sp>
+        <p:nvSpPr>
+          <p:cNvPr id="56" name="TextBox 55"/>
+          <p:cNvSpPr txBox="1"/>
+          <p:nvPr/>
+        </p:nvSpPr>
+        <p:spPr>
+          <a:xfrm>
+            <a:off x="6035040" y="3273552"/>
+            <a:ext cx="1188720" cy="329184"/>
+          </a:xfrm>
+          <a:prstGeom prst="rect">
+            <a:avLst/>
+          </a:prstGeom>
+          <a:noFill/>
+        </p:spPr>
+        <p:txBody>
+          <a:bodyPr wrap="square">
+            <a:spAutoFit/>
+          </a:bodyPr>
+          <a:lstStyle/>
+          <a:p>
+            <a:pPr algn="l"/>
+            <a:r>
+              <a:rPr sz="1100" b="0" i="0">
+                <a:solidFill>
+                  <a:srgbClr val="1A1A1A"/>
+                </a:solidFill>
+              </a:rPr>
+              <a:t>P8</a:t>
+            </a:r>
+          </a:p>
+        </p:txBody>
+      </p:sp>
+      <p:sp>
+        <p:nvSpPr>
+          <p:cNvPr id="57" name="Rectangle 56"/>
+          <p:cNvSpPr/>
+          <p:nvPr/>
+        </p:nvSpPr>
+        <p:spPr>
+          <a:xfrm>
+            <a:off x="7269480" y="3236976"/>
+            <a:ext cx="1280160" cy="329184"/>
+          </a:xfrm>
+          <a:prstGeom prst="rect">
+            <a:avLst/>
+          </a:prstGeom>
+          <a:solidFill>
+            <a:srgbClr val="FFFFFF"/>
+          </a:solidFill>
+          <a:ln w="12700">
+            <a:solidFill>
+              <a:srgbClr val="D6E4F5"/>
+            </a:solidFill>
+          </a:ln>
+        </p:spPr>
+        <p:style>
+          <a:lnRef idx="1">
+            <a:schemeClr val="accent1"/>
+          </a:lnRef>
+          <a:fillRef idx="3">
+            <a:schemeClr val="accent1"/>
+          </a:fillRef>
+          <a:effectRef idx="2">
+            <a:schemeClr val="accent1"/>
+          </a:effectRef>
+          <a:fontRef idx="minor">
+            <a:schemeClr val="lt1"/>
+          </a:fontRef>
+        </p:style>
+        <p:txBody>
+          <a:bodyPr rtlCol="0" anchor="ctr"/>
+          <a:lstStyle/>
+          <a:p>
+            <a:pPr algn="ctr"/>
+          </a:p>
+        </p:txBody>
+      </p:sp>
+      <p:sp>
+        <p:nvSpPr>
+          <p:cNvPr id="58" name="TextBox 57"/>
+          <p:cNvSpPr txBox="1"/>
+          <p:nvPr/>
+        </p:nvSpPr>
+        <p:spPr>
+          <a:xfrm>
+            <a:off x="7315200" y="3273552"/>
+            <a:ext cx="1188720" cy="329184"/>
+          </a:xfrm>
+          <a:prstGeom prst="rect">
+            <a:avLst/>
+          </a:prstGeom>
+          <a:noFill/>
+        </p:spPr>
+        <p:txBody>
+          <a:bodyPr wrap="square">
+            <a:spAutoFit/>
+          </a:bodyPr>
+          <a:lstStyle/>
+          <a:p>
+            <a:pPr algn="ctr"/>
+            <a:r>
+              <a:rPr sz="1100" b="0" i="0">
+                <a:solidFill>
+                  <a:srgbClr val="1A1A1A"/>
+                </a:solidFill>
+              </a:rPr>
+              <a:t>Normal</a:t>
+            </a:r>
+          </a:p>
+        </p:txBody>
+      </p:sp>
+      <p:sp>
+        <p:nvSpPr>
+          <p:cNvPr id="59" name="Rectangle 58"/>
+          <p:cNvSpPr/>
+          <p:nvPr/>
+        </p:nvSpPr>
+        <p:spPr>
+          <a:xfrm>
+            <a:off x="8549640" y="3236976"/>
+            <a:ext cx="2011680" cy="329184"/>
+          </a:xfrm>
+          <a:prstGeom prst="rect">
+            <a:avLst/>
+          </a:prstGeom>
+          <a:solidFill>
+            <a:srgbClr val="FFFFFF"/>
+          </a:solidFill>
+          <a:ln w="12700">
+            <a:solidFill>
+              <a:srgbClr val="D6E4F5"/>
+            </a:solidFill>
+          </a:ln>
+        </p:spPr>
+        <p:style>
+          <a:lnRef idx="1">
+            <a:schemeClr val="accent1"/>
+          </a:lnRef>
+          <a:fillRef idx="3">
+            <a:schemeClr val="accent1"/>
+          </a:fillRef>
+          <a:effectRef idx="2">
+            <a:schemeClr val="accent1"/>
+          </a:effectRef>
+          <a:fontRef idx="minor">
+            <a:schemeClr val="lt1"/>
+          </a:fontRef>
+        </p:style>
+        <p:txBody>
+          <a:bodyPr rtlCol="0" anchor="ctr"/>
+          <a:lstStyle/>
+          <a:p>
+            <a:pPr algn="ctr"/>
+          </a:p>
+        </p:txBody>
+      </p:sp>
+      <p:sp>
+        <p:nvSpPr>
+          <p:cNvPr id="60" name="TextBox 59"/>
+          <p:cNvSpPr txBox="1"/>
+          <p:nvPr/>
+        </p:nvSpPr>
+        <p:spPr>
+          <a:xfrm>
+            <a:off x="8595360" y="3273552"/>
+            <a:ext cx="1920240" cy="329184"/>
+          </a:xfrm>
+          <a:prstGeom prst="rect">
+            <a:avLst/>
+          </a:prstGeom>
+          <a:noFill/>
+        </p:spPr>
+        <p:txBody>
+          <a:bodyPr wrap="square">
+            <a:spAutoFit/>
+          </a:bodyPr>
+          <a:lstStyle/>
+          <a:p>
+            <a:pPr algn="ctr"/>
+            <a:r>
+              <a:rPr sz="1100" b="0" i="0">
+                <a:solidFill>
+                  <a:srgbClr val="1A1A1A"/>
+                </a:solidFill>
+              </a:rPr>
+              <a:t>Sin alerta ✓</a:t>
+            </a:r>
+          </a:p>
+        </p:txBody>
+      </p:sp>
+      <p:sp>
+        <p:nvSpPr>
+          <p:cNvPr id="61" name="Rectangle 60"/>
+          <p:cNvSpPr/>
+          <p:nvPr/>
+        </p:nvSpPr>
+        <p:spPr>
+          <a:xfrm>
+            <a:off x="10561320" y="3236976"/>
+            <a:ext cx="1097280" cy="329184"/>
+          </a:xfrm>
+          <a:prstGeom prst="rect">
+            <a:avLst/>
+          </a:prstGeom>
+          <a:solidFill>
+            <a:srgbClr val="FFFFFF"/>
+          </a:solidFill>
+          <a:ln w="12700">
+            <a:solidFill>
+              <a:srgbClr val="D6E4F5"/>
+            </a:solidFill>
+          </a:ln>
+        </p:spPr>
+        <p:style>
+          <a:lnRef idx="1">
+            <a:schemeClr val="accent1"/>
+          </a:lnRef>
+          <a:fillRef idx="3">
+            <a:schemeClr val="accent1"/>
+          </a:fillRef>
+          <a:effectRef idx="2">
+            <a:schemeClr val="accent1"/>
+          </a:effectRef>
+          <a:fontRef idx="minor">
+            <a:schemeClr val="lt1"/>
+          </a:fontRef>
+        </p:style>
+        <p:txBody>
+          <a:bodyPr rtlCol="0" anchor="ctr"/>
+          <a:lstStyle/>
+          <a:p>
+            <a:pPr algn="ctr"/>
+          </a:p>
+        </p:txBody>
+      </p:sp>
+      <p:sp>
+        <p:nvSpPr>
+          <p:cNvPr id="62" name="TextBox 61"/>
+          <p:cNvSpPr txBox="1"/>
+          <p:nvPr/>
+        </p:nvSpPr>
+        <p:spPr>
+          <a:xfrm>
+            <a:off x="10607040" y="3273552"/>
+            <a:ext cx="1005840" cy="329184"/>
+          </a:xfrm>
+          <a:prstGeom prst="rect">
+            <a:avLst/>
+          </a:prstGeom>
+          <a:noFill/>
+        </p:spPr>
+        <p:txBody>
+          <a:bodyPr wrap="square">
+            <a:spAutoFit/>
+          </a:bodyPr>
+          <a:lstStyle/>
+          <a:p>
+            <a:pPr algn="ctr"/>
+            <a:r>
+              <a:rPr sz="1100" b="0" i="0">
+                <a:solidFill>
+                  <a:srgbClr val="1A1A1A"/>
+                </a:solidFill>
+              </a:rPr>
+              <a:t>—</a:t>
+            </a:r>
+          </a:p>
+        </p:txBody>
+      </p:sp>
+      <p:sp>
+        <p:nvSpPr>
+          <p:cNvPr id="63" name="Rectangle 62"/>
+          <p:cNvSpPr/>
+          <p:nvPr/>
+        </p:nvSpPr>
+        <p:spPr>
+          <a:xfrm>
+            <a:off x="5989320" y="3566160"/>
+            <a:ext cx="1280160" cy="329184"/>
+          </a:xfrm>
+          <a:prstGeom prst="rect">
+            <a:avLst/>
+          </a:prstGeom>
+          <a:solidFill>
+            <a:srgbClr val="D6E4F5"/>
+          </a:solidFill>
+          <a:ln w="12700">
+            <a:solidFill>
+              <a:srgbClr val="D6E4F5"/>
+            </a:solidFill>
+          </a:ln>
+        </p:spPr>
+        <p:style>
+          <a:lnRef idx="1">
+            <a:schemeClr val="accent1"/>
+          </a:lnRef>
+          <a:fillRef idx="3">
+            <a:schemeClr val="accent1"/>
+          </a:fillRef>
+          <a:effectRef idx="2">
+            <a:schemeClr val="accent1"/>
+          </a:effectRef>
+          <a:fontRef idx="minor">
+            <a:schemeClr val="lt1"/>
+          </a:fontRef>
+        </p:style>
+        <p:txBody>
+          <a:bodyPr rtlCol="0" anchor="ctr"/>
+          <a:lstStyle/>
+          <a:p>
+            <a:pPr algn="ctr"/>
+          </a:p>
+        </p:txBody>
+      </p:sp>
+      <p:sp>
+        <p:nvSpPr>
+          <p:cNvPr id="64" name="TextBox 63"/>
+          <p:cNvSpPr txBox="1"/>
+          <p:nvPr/>
+        </p:nvSpPr>
+        <p:spPr>
+          <a:xfrm>
+            <a:off x="6035040" y="3602736"/>
+            <a:ext cx="1188720" cy="329184"/>
+          </a:xfrm>
+          <a:prstGeom prst="rect">
+            <a:avLst/>
+          </a:prstGeom>
+          <a:noFill/>
+        </p:spPr>
+        <p:txBody>
+          <a:bodyPr wrap="square">
+            <a:spAutoFit/>
+          </a:bodyPr>
+          <a:lstStyle/>
+          <a:p>
+            <a:pPr algn="l"/>
+            <a:r>
+              <a:rPr sz="1100" b="0" i="0">
+                <a:solidFill>
+                  <a:srgbClr val="1A1A1A"/>
+                </a:solidFill>
+              </a:rPr>
+              <a:t>P9-P10</a:t>
+            </a:r>
+          </a:p>
+        </p:txBody>
+      </p:sp>
+      <p:sp>
+        <p:nvSpPr>
+          <p:cNvPr id="65" name="Rectangle 64"/>
+          <p:cNvSpPr/>
+          <p:nvPr/>
+        </p:nvSpPr>
+        <p:spPr>
+          <a:xfrm>
+            <a:off x="7269480" y="3566160"/>
+            <a:ext cx="1280160" cy="329184"/>
+          </a:xfrm>
+          <a:prstGeom prst="rect">
+            <a:avLst/>
+          </a:prstGeom>
+          <a:solidFill>
+            <a:srgbClr val="D6E4F5"/>
+          </a:solidFill>
+          <a:ln w="12700">
+            <a:solidFill>
+              <a:srgbClr val="D6E4F5"/>
+            </a:solidFill>
+          </a:ln>
+        </p:spPr>
+        <p:style>
+          <a:lnRef idx="1">
+            <a:schemeClr val="accent1"/>
+          </a:lnRef>
+          <a:fillRef idx="3">
+            <a:schemeClr val="accent1"/>
+          </a:fillRef>
+          <a:effectRef idx="2">
+            <a:schemeClr val="accent1"/>
+          </a:effectRef>
+          <a:fontRef idx="minor">
+            <a:schemeClr val="lt1"/>
+          </a:fontRef>
+        </p:style>
+        <p:txBody>
+          <a:bodyPr rtlCol="0" anchor="ctr"/>
+          <a:lstStyle/>
+          <a:p>
+            <a:pPr algn="ctr"/>
+          </a:p>
+        </p:txBody>
+      </p:sp>
+      <p:sp>
+        <p:nvSpPr>
+          <p:cNvPr id="66" name="TextBox 65"/>
+          <p:cNvSpPr txBox="1"/>
+          <p:nvPr/>
+        </p:nvSpPr>
+        <p:spPr>
+          <a:xfrm>
+            <a:off x="7315200" y="3602736"/>
+            <a:ext cx="1188720" cy="329184"/>
+          </a:xfrm>
+          <a:prstGeom prst="rect">
+            <a:avLst/>
+          </a:prstGeom>
+          <a:noFill/>
+        </p:spPr>
+        <p:txBody>
+          <a:bodyPr wrap="square">
+            <a:spAutoFit/>
+          </a:bodyPr>
+          <a:lstStyle/>
+          <a:p>
+            <a:pPr algn="ctr"/>
+            <a:r>
+              <a:rPr sz="1100" b="0" i="0">
+                <a:solidFill>
+                  <a:srgbClr val="1A1A1A"/>
+                </a:solidFill>
+              </a:rPr>
+              <a:t>Normal</a:t>
+            </a:r>
+          </a:p>
+        </p:txBody>
+      </p:sp>
+      <p:sp>
+        <p:nvSpPr>
+          <p:cNvPr id="67" name="Rectangle 66"/>
+          <p:cNvSpPr/>
+          <p:nvPr/>
+        </p:nvSpPr>
+        <p:spPr>
+          <a:xfrm>
+            <a:off x="8549640" y="3566160"/>
+            <a:ext cx="2011680" cy="329184"/>
+          </a:xfrm>
+          <a:prstGeom prst="rect">
+            <a:avLst/>
+          </a:prstGeom>
+          <a:solidFill>
+            <a:srgbClr val="D6E4F5"/>
+          </a:solidFill>
+          <a:ln w="12700">
+            <a:solidFill>
+              <a:srgbClr val="D6E4F5"/>
+            </a:solidFill>
+          </a:ln>
+        </p:spPr>
+        <p:style>
+          <a:lnRef idx="1">
+            <a:schemeClr val="accent1"/>
+          </a:lnRef>
+          <a:fillRef idx="3">
+            <a:schemeClr val="accent1"/>
+          </a:fillRef>
+          <a:effectRef idx="2">
+            <a:schemeClr val="accent1"/>
+          </a:effectRef>
+          <a:fontRef idx="minor">
+            <a:schemeClr val="lt1"/>
+          </a:fontRef>
+        </p:style>
+        <p:txBody>
+          <a:bodyPr rtlCol="0" anchor="ctr"/>
+          <a:lstStyle/>
+          <a:p>
+            <a:pPr algn="ctr"/>
+          </a:p>
+        </p:txBody>
+      </p:sp>
+      <p:sp>
+        <p:nvSpPr>
+          <p:cNvPr id="68" name="TextBox 67"/>
+          <p:cNvSpPr txBox="1"/>
+          <p:nvPr/>
+        </p:nvSpPr>
+        <p:spPr>
+          <a:xfrm>
+            <a:off x="8595360" y="3602736"/>
+            <a:ext cx="1920240" cy="329184"/>
+          </a:xfrm>
+          <a:prstGeom prst="rect">
+            <a:avLst/>
+          </a:prstGeom>
+          <a:noFill/>
+        </p:spPr>
+        <p:txBody>
+          <a:bodyPr wrap="square">
+            <a:spAutoFit/>
+          </a:bodyPr>
+          <a:lstStyle/>
+          <a:p>
+            <a:pPr algn="ctr"/>
+            <a:r>
+              <a:rPr sz="1100" b="0" i="0">
+                <a:solidFill>
+                  <a:srgbClr val="1A1A1A"/>
+                </a:solidFill>
+              </a:rPr>
+              <a:t>Sin alerta ✓</a:t>
+            </a:r>
+          </a:p>
+        </p:txBody>
+      </p:sp>
+      <p:sp>
+        <p:nvSpPr>
+          <p:cNvPr id="69" name="Rectangle 68"/>
+          <p:cNvSpPr/>
+          <p:nvPr/>
+        </p:nvSpPr>
+        <p:spPr>
+          <a:xfrm>
+            <a:off x="10561320" y="3566160"/>
+            <a:ext cx="1097280" cy="329184"/>
+          </a:xfrm>
+          <a:prstGeom prst="rect">
+            <a:avLst/>
+          </a:prstGeom>
+          <a:solidFill>
+            <a:srgbClr val="D6E4F5"/>
+          </a:solidFill>
+          <a:ln w="12700">
+            <a:solidFill>
+              <a:srgbClr val="D6E4F5"/>
+            </a:solidFill>
+          </a:ln>
+        </p:spPr>
+        <p:style>
+          <a:lnRef idx="1">
+            <a:schemeClr val="accent1"/>
+          </a:lnRef>
+          <a:fillRef idx="3">
+            <a:schemeClr val="accent1"/>
+          </a:fillRef>
+          <a:effectRef idx="2">
+            <a:schemeClr val="accent1"/>
+          </a:effectRef>
+          <a:fontRef idx="minor">
+            <a:schemeClr val="lt1"/>
+          </a:fontRef>
+        </p:style>
+        <p:txBody>
+          <a:bodyPr rtlCol="0" anchor="ctr"/>
+          <a:lstStyle/>
+          <a:p>
+            <a:pPr algn="ctr"/>
+          </a:p>
+        </p:txBody>
+      </p:sp>
+      <p:sp>
+        <p:nvSpPr>
+          <p:cNvPr id="70" name="TextBox 69"/>
+          <p:cNvSpPr txBox="1"/>
+          <p:nvPr/>
+        </p:nvSpPr>
+        <p:spPr>
+          <a:xfrm>
+            <a:off x="10607040" y="3602736"/>
+            <a:ext cx="1005840" cy="329184"/>
+          </a:xfrm>
+          <a:prstGeom prst="rect">
+            <a:avLst/>
+          </a:prstGeom>
+          <a:noFill/>
+        </p:spPr>
+        <p:txBody>
+          <a:bodyPr wrap="square">
+            <a:spAutoFit/>
+          </a:bodyPr>
+          <a:lstStyle/>
+          <a:p>
+            <a:pPr algn="ctr"/>
+            <a:r>
+              <a:rPr sz="1100" b="0" i="0">
+                <a:solidFill>
+                  <a:srgbClr val="1A1A1A"/>
+                </a:solidFill>
+              </a:rPr>
+              <a:t>—</a:t>
+            </a:r>
+          </a:p>
+        </p:txBody>
+      </p:sp>
+      <p:sp>
+        <p:nvSpPr>
+          <p:cNvPr id="71" name="Rectangle 70"/>
+          <p:cNvSpPr/>
+          <p:nvPr/>
+        </p:nvSpPr>
+        <p:spPr>
+          <a:xfrm>
+            <a:off x="5943600" y="4572000"/>
+            <a:ext cx="5943600" cy="2011680"/>
+          </a:xfrm>
+          <a:prstGeom prst="rect">
+            <a:avLst/>
+          </a:prstGeom>
+          <a:solidFill>
+            <a:srgbClr val="002D62"/>
+          </a:solidFill>
+          <a:ln>
+            <a:noFill/>
+          </a:ln>
+        </p:spPr>
+        <p:style>
+          <a:lnRef idx="1">
+            <a:schemeClr val="accent1"/>
+          </a:lnRef>
+          <a:fillRef idx="3">
+            <a:schemeClr val="accent1"/>
+          </a:fillRef>
+          <a:effectRef idx="2">
+            <a:schemeClr val="accent1"/>
+          </a:effectRef>
+          <a:fontRef idx="minor">
+            <a:schemeClr val="lt1"/>
+          </a:fontRef>
+        </p:style>
+        <p:txBody>
+          <a:bodyPr rtlCol="0" anchor="ctr"/>
+          <a:lstStyle/>
+          <a:p>
+            <a:pPr algn="ctr"/>
+          </a:p>
+        </p:txBody>
+      </p:sp>
+      <p:sp>
+        <p:nvSpPr>
+          <p:cNvPr id="72" name="TextBox 71"/>
+          <p:cNvSpPr txBox="1"/>
+          <p:nvPr/>
+        </p:nvSpPr>
+        <p:spPr>
+          <a:xfrm>
+            <a:off x="6080760" y="4617720"/>
+            <a:ext cx="5669280" cy="320040"/>
+          </a:xfrm>
+          <a:prstGeom prst="rect">
+            <a:avLst/>
+          </a:prstGeom>
+          <a:noFill/>
+        </p:spPr>
+        <p:txBody>
+          <a:bodyPr wrap="square">
+            <a:spAutoFit/>
+          </a:bodyPr>
+          <a:lstStyle/>
+          <a:p>
+            <a:pPr algn="l"/>
+            <a:r>
               <a:rPr sz="1200" b="1" i="0">
                 <a:solidFill>
-                  <a:srgbClr val="002D62"/>
-                </a:solidFill>
-              </a:rPr>
-              <a:t>Defensa justificada del umbral FPR=20.47%</a:t>
-            </a:r>
-          </a:p>
-        </p:txBody>
-      </p:sp>
-      <p:sp>
-        <p:nvSpPr>
-          <p:cNvPr id="32" name="TextBox 31"/>
-          <p:cNvSpPr txBox="1"/>
-          <p:nvPr/>
-        </p:nvSpPr>
-        <p:spPr>
-          <a:xfrm>
-            <a:off x="960120" y="5824728"/>
-            <a:ext cx="10789920" cy="438912"/>
+                  <a:srgbClr val="FFFFFF"/>
+                </a:solidFill>
+              </a:rPr>
+              <a:t>Métricas del predictor</a:t>
+            </a:r>
+          </a:p>
+        </p:txBody>
+      </p:sp>
+      <p:sp>
+        <p:nvSpPr>
+          <p:cNvPr id="73" name="TextBox 72"/>
+          <p:cNvSpPr txBox="1"/>
+          <p:nvPr/>
+        </p:nvSpPr>
+        <p:spPr>
+          <a:xfrm>
+            <a:off x="5989320" y="4983480"/>
+            <a:ext cx="3017520" cy="320040"/>
           </a:xfrm>
           <a:prstGeom prst="rect">
             <a:avLst/>
@@ -17242,12 +18824,250 @@
           <a:p>
             <a:pPr algn="l"/>
             <a:r>
-              <a:rPr sz="1100" b="0" i="0">
-                <a:solidFill>
-                  <a:srgbClr val="1A1A1A"/>
-                </a:solidFill>
-              </a:rPr>
-              <a:t>Reducir FPR a ≤5% sacrificaría la detección de SYN Flood (score≈−0.49 &gt; τ1=−0.555). El índice de Youden es el umbral metodológicamente correcto en este contexto.</a:t>
+              <a:rPr sz="1200" b="0" i="0">
+                <a:solidFill>
+                  <a:srgbClr val="D6E4F5"/>
+                </a:solidFill>
+              </a:rPr>
+              <a:t>  TPR ataques:</a:t>
+            </a:r>
+          </a:p>
+        </p:txBody>
+      </p:sp>
+      <p:sp>
+        <p:nvSpPr>
+          <p:cNvPr id="74" name="TextBox 73"/>
+          <p:cNvSpPr txBox="1"/>
+          <p:nvPr/>
+        </p:nvSpPr>
+        <p:spPr>
+          <a:xfrm>
+            <a:off x="9006840" y="4983480"/>
+            <a:ext cx="2743200" cy="320040"/>
+          </a:xfrm>
+          <a:prstGeom prst="rect">
+            <a:avLst/>
+          </a:prstGeom>
+          <a:noFill/>
+        </p:spPr>
+        <p:txBody>
+          <a:bodyPr wrap="square">
+            <a:spAutoFit/>
+          </a:bodyPr>
+          <a:lstStyle/>
+          <a:p>
+            <a:pPr algn="l"/>
+            <a:r>
+              <a:rPr sz="1200" b="1" i="0">
+                <a:solidFill>
+                  <a:srgbClr val="F5A623"/>
+                </a:solidFill>
+              </a:rPr>
+              <a:t>2/2 = 100%</a:t>
+            </a:r>
+          </a:p>
+        </p:txBody>
+      </p:sp>
+      <p:sp>
+        <p:nvSpPr>
+          <p:cNvPr id="75" name="TextBox 74"/>
+          <p:cNvSpPr txBox="1"/>
+          <p:nvPr/>
+        </p:nvSpPr>
+        <p:spPr>
+          <a:xfrm>
+            <a:off x="5989320" y="5367528"/>
+            <a:ext cx="3017520" cy="320040"/>
+          </a:xfrm>
+          <a:prstGeom prst="rect">
+            <a:avLst/>
+          </a:prstGeom>
+          <a:noFill/>
+        </p:spPr>
+        <p:txBody>
+          <a:bodyPr wrap="square">
+            <a:spAutoFit/>
+          </a:bodyPr>
+          <a:lstStyle/>
+          <a:p>
+            <a:pPr algn="l"/>
+            <a:r>
+              <a:rPr sz="1200" b="0" i="0">
+                <a:solidFill>
+                  <a:srgbClr val="D6E4F5"/>
+                </a:solidFill>
+              </a:rPr>
+              <a:t>  FPR normal:</a:t>
+            </a:r>
+          </a:p>
+        </p:txBody>
+      </p:sp>
+      <p:sp>
+        <p:nvSpPr>
+          <p:cNvPr id="76" name="TextBox 75"/>
+          <p:cNvSpPr txBox="1"/>
+          <p:nvPr/>
+        </p:nvSpPr>
+        <p:spPr>
+          <a:xfrm>
+            <a:off x="9006840" y="5367528"/>
+            <a:ext cx="2743200" cy="320040"/>
+          </a:xfrm>
+          <a:prstGeom prst="rect">
+            <a:avLst/>
+          </a:prstGeom>
+          <a:noFill/>
+        </p:spPr>
+        <p:txBody>
+          <a:bodyPr wrap="square">
+            <a:spAutoFit/>
+          </a:bodyPr>
+          <a:lstStyle/>
+          <a:p>
+            <a:pPr algn="l"/>
+            <a:r>
+              <a:rPr sz="1200" b="1" i="0">
+                <a:solidFill>
+                  <a:srgbClr val="F5A623"/>
+                </a:solidFill>
+              </a:rPr>
+              <a:t>0/4 = 0%</a:t>
+            </a:r>
+          </a:p>
+        </p:txBody>
+      </p:sp>
+      <p:sp>
+        <p:nvSpPr>
+          <p:cNvPr id="77" name="TextBox 76"/>
+          <p:cNvSpPr txBox="1"/>
+          <p:nvPr/>
+        </p:nvSpPr>
+        <p:spPr>
+          <a:xfrm>
+            <a:off x="5989320" y="5751576"/>
+            <a:ext cx="3017520" cy="320040"/>
+          </a:xfrm>
+          <a:prstGeom prst="rect">
+            <a:avLst/>
+          </a:prstGeom>
+          <a:noFill/>
+        </p:spPr>
+        <p:txBody>
+          <a:bodyPr wrap="square">
+            <a:spAutoFit/>
+          </a:bodyPr>
+          <a:lstStyle/>
+          <a:p>
+            <a:pPr algn="l"/>
+            <a:r>
+              <a:rPr sz="1200" b="0" i="0">
+                <a:solidFill>
+                  <a:srgbClr val="D6E4F5"/>
+                </a:solidFill>
+              </a:rPr>
+              <a:t>  P media ataque:</a:t>
+            </a:r>
+          </a:p>
+        </p:txBody>
+      </p:sp>
+      <p:sp>
+        <p:nvSpPr>
+          <p:cNvPr id="78" name="TextBox 77"/>
+          <p:cNvSpPr txBox="1"/>
+          <p:nvPr/>
+        </p:nvSpPr>
+        <p:spPr>
+          <a:xfrm>
+            <a:off x="9006840" y="5751576"/>
+            <a:ext cx="2743200" cy="320040"/>
+          </a:xfrm>
+          <a:prstGeom prst="rect">
+            <a:avLst/>
+          </a:prstGeom>
+          <a:noFill/>
+        </p:spPr>
+        <p:txBody>
+          <a:bodyPr wrap="square">
+            <a:spAutoFit/>
+          </a:bodyPr>
+          <a:lstStyle/>
+          <a:p>
+            <a:pPr algn="l"/>
+            <a:r>
+              <a:rPr sz="1200" b="1" i="0">
+                <a:solidFill>
+                  <a:srgbClr val="F5A623"/>
+                </a:solidFill>
+              </a:rPr>
+              <a:t>82.4%</a:t>
+            </a:r>
+          </a:p>
+        </p:txBody>
+      </p:sp>
+      <p:sp>
+        <p:nvSpPr>
+          <p:cNvPr id="79" name="TextBox 78"/>
+          <p:cNvSpPr txBox="1"/>
+          <p:nvPr/>
+        </p:nvSpPr>
+        <p:spPr>
+          <a:xfrm>
+            <a:off x="5989320" y="6135624"/>
+            <a:ext cx="3017520" cy="320040"/>
+          </a:xfrm>
+          <a:prstGeom prst="rect">
+            <a:avLst/>
+          </a:prstGeom>
+          <a:noFill/>
+        </p:spPr>
+        <p:txBody>
+          <a:bodyPr wrap="square">
+            <a:spAutoFit/>
+          </a:bodyPr>
+          <a:lstStyle/>
+          <a:p>
+            <a:pPr algn="l"/>
+            <a:r>
+              <a:rPr sz="1200" b="0" i="0">
+                <a:solidFill>
+                  <a:srgbClr val="D6E4F5"/>
+                </a:solidFill>
+              </a:rPr>
+              <a:t>  Servicios:</a:t>
+            </a:r>
+          </a:p>
+        </p:txBody>
+      </p:sp>
+      <p:sp>
+        <p:nvSpPr>
+          <p:cNvPr id="80" name="TextBox 79"/>
+          <p:cNvSpPr txBox="1"/>
+          <p:nvPr/>
+        </p:nvSpPr>
+        <p:spPr>
+          <a:xfrm>
+            <a:off x="9006840" y="6135624"/>
+            <a:ext cx="2743200" cy="320040"/>
+          </a:xfrm>
+          <a:prstGeom prst="rect">
+            <a:avLst/>
+          </a:prstGeom>
+          <a:noFill/>
+        </p:spPr>
+        <p:txBody>
+          <a:bodyPr wrap="square">
+            <a:spAutoFit/>
+          </a:bodyPr>
+          <a:lstStyle/>
+          <a:p>
+            <a:pPr algn="l"/>
+            <a:r>
+              <a:rPr sz="1200" b="1" i="0">
+                <a:solidFill>
+                  <a:srgbClr val="F5A623"/>
+                </a:solidFill>
+              </a:rPr>
+              <a:t>3 activos</a:t>
             </a:r>
           </a:p>
         </p:txBody>
@@ -17385,7 +19205,7 @@
                   <a:srgbClr val="FFFFFF"/>
                 </a:solidFill>
               </a:rPr>
-              <a:t>Trabajo Futuro  /  Preguntas</a:t>
+              <a:t>Conclusiones</a:t>
             </a:r>
           </a:p>
         </p:txBody>
@@ -17419,7 +19239,7 @@
                   <a:srgbClr val="D6E4F5"/>
                 </a:solidFill>
               </a:rPr>
-              <a:t>Líneas de extensión del sistema</a:t>
+              <a:t>Lo que se logró — impacto y contribución</a:t>
             </a:r>
           </a:p>
         </p:txBody>
@@ -17496,7 +19316,7 @@
                   <a:srgbClr val="FFFFFF"/>
                 </a:solidFill>
               </a:rPr>
-              <a:t>PPI — UPeU 2026  |  Rubén Salazar Tocas  |  16/16</a:t>
+              <a:t>PPI — UPeU 2026  |  Rubén Salazar Tocas  |  16/17</a:t>
             </a:r>
           </a:p>
         </p:txBody>
@@ -17509,8 +19329,85 @@
         </p:nvSpPr>
         <p:spPr>
           <a:xfrm>
-            <a:off x="274320" y="1463040"/>
-            <a:ext cx="5760720" cy="5120640"/>
+            <a:off x="274320" y="1508760"/>
+            <a:ext cx="457200" cy="868680"/>
+          </a:xfrm>
+          <a:prstGeom prst="rect">
+            <a:avLst/>
+          </a:prstGeom>
+          <a:solidFill>
+            <a:srgbClr val="1A7C4A"/>
+          </a:solidFill>
+          <a:ln>
+            <a:noFill/>
+          </a:ln>
+        </p:spPr>
+        <p:style>
+          <a:lnRef idx="1">
+            <a:schemeClr val="accent1"/>
+          </a:lnRef>
+          <a:fillRef idx="3">
+            <a:schemeClr val="accent1"/>
+          </a:fillRef>
+          <a:effectRef idx="2">
+            <a:schemeClr val="accent1"/>
+          </a:effectRef>
+          <a:fontRef idx="minor">
+            <a:schemeClr val="lt1"/>
+          </a:fontRef>
+        </p:style>
+        <p:txBody>
+          <a:bodyPr rtlCol="0" anchor="ctr"/>
+          <a:lstStyle/>
+          <a:p>
+            <a:pPr algn="ctr"/>
+          </a:p>
+        </p:txBody>
+      </p:sp>
+      <p:sp>
+        <p:nvSpPr>
+          <p:cNvPr id="9" name="TextBox 8"/>
+          <p:cNvSpPr txBox="1"/>
+          <p:nvPr/>
+        </p:nvSpPr>
+        <p:spPr>
+          <a:xfrm>
+            <a:off x="274320" y="1673352"/>
+            <a:ext cx="457200" cy="548640"/>
+          </a:xfrm>
+          <a:prstGeom prst="rect">
+            <a:avLst/>
+          </a:prstGeom>
+          <a:noFill/>
+        </p:spPr>
+        <p:txBody>
+          <a:bodyPr wrap="square">
+            <a:spAutoFit/>
+          </a:bodyPr>
+          <a:lstStyle/>
+          <a:p>
+            <a:pPr algn="ctr"/>
+            <a:r>
+              <a:rPr sz="2000" b="1" i="0">
+                <a:solidFill>
+                  <a:srgbClr val="FFFFFF"/>
+                </a:solidFill>
+              </a:rPr>
+              <a:t>1</a:t>
+            </a:r>
+          </a:p>
+        </p:txBody>
+      </p:sp>
+      <p:sp>
+        <p:nvSpPr>
+          <p:cNvPr id="10" name="Rectangle 9"/>
+          <p:cNvSpPr/>
+          <p:nvPr/>
+        </p:nvSpPr>
+        <p:spPr>
+          <a:xfrm>
+            <a:off x="822960" y="1508760"/>
+            <a:ext cx="11091672" cy="868680"/>
           </a:xfrm>
           <a:prstGeom prst="rect">
             <a:avLst/>
@@ -17548,6 +19445,1128 @@
       </p:sp>
       <p:sp>
         <p:nvSpPr>
+          <p:cNvPr id="11" name="TextBox 10"/>
+          <p:cNvSpPr txBox="1"/>
+          <p:nvPr/>
+        </p:nvSpPr>
+        <p:spPr>
+          <a:xfrm>
+            <a:off x="960120" y="1563624"/>
+            <a:ext cx="10789920" cy="320040"/>
+          </a:xfrm>
+          <a:prstGeom prst="rect">
+            <a:avLst/>
+          </a:prstGeom>
+          <a:noFill/>
+        </p:spPr>
+        <p:txBody>
+          <a:bodyPr wrap="square">
+            <a:spAutoFit/>
+          </a:bodyPr>
+          <a:lstStyle/>
+          <a:p>
+            <a:pPr algn="l"/>
+            <a:r>
+              <a:rPr sz="1200" b="1" i="0">
+                <a:solidFill>
+                  <a:srgbClr val="002D62"/>
+                </a:solidFill>
+              </a:rPr>
+              <a:t>Sistema funcional end-to-end</a:t>
+            </a:r>
+          </a:p>
+        </p:txBody>
+      </p:sp>
+      <p:sp>
+        <p:nvSpPr>
+          <p:cNvPr id="12" name="TextBox 11"/>
+          <p:cNvSpPr txBox="1"/>
+          <p:nvPr/>
+        </p:nvSpPr>
+        <p:spPr>
+          <a:xfrm>
+            <a:off x="960120" y="1874520"/>
+            <a:ext cx="10789920" cy="438912"/>
+          </a:xfrm>
+          <a:prstGeom prst="rect">
+            <a:avLst/>
+          </a:prstGeom>
+          <a:noFill/>
+        </p:spPr>
+        <p:txBody>
+          <a:bodyPr wrap="square">
+            <a:spAutoFit/>
+          </a:bodyPr>
+          <a:lstStyle/>
+          <a:p>
+            <a:pPr algn="l"/>
+            <a:r>
+              <a:rPr sz="1100" b="0" i="0">
+                <a:solidFill>
+                  <a:srgbClr val="1A1A1A"/>
+                </a:solidFill>
+              </a:rPr>
+              <a:t>Se implementó y validó un pipeline completo: captura (Suricata) → preproceso → Isolation Forest → motor tiempo real → control inline (ipset). Todas las fases F1-F6 operativas en laboratorio real.</a:t>
+            </a:r>
+          </a:p>
+        </p:txBody>
+      </p:sp>
+      <p:sp>
+        <p:nvSpPr>
+          <p:cNvPr id="13" name="Rectangle 12"/>
+          <p:cNvSpPr/>
+          <p:nvPr/>
+        </p:nvSpPr>
+        <p:spPr>
+          <a:xfrm>
+            <a:off x="274320" y="2496312"/>
+            <a:ext cx="457200" cy="868680"/>
+          </a:xfrm>
+          <a:prstGeom prst="rect">
+            <a:avLst/>
+          </a:prstGeom>
+          <a:solidFill>
+            <a:srgbClr val="1A7C4A"/>
+          </a:solidFill>
+          <a:ln>
+            <a:noFill/>
+          </a:ln>
+        </p:spPr>
+        <p:style>
+          <a:lnRef idx="1">
+            <a:schemeClr val="accent1"/>
+          </a:lnRef>
+          <a:fillRef idx="3">
+            <a:schemeClr val="accent1"/>
+          </a:fillRef>
+          <a:effectRef idx="2">
+            <a:schemeClr val="accent1"/>
+          </a:effectRef>
+          <a:fontRef idx="minor">
+            <a:schemeClr val="lt1"/>
+          </a:fontRef>
+        </p:style>
+        <p:txBody>
+          <a:bodyPr rtlCol="0" anchor="ctr"/>
+          <a:lstStyle/>
+          <a:p>
+            <a:pPr algn="ctr"/>
+          </a:p>
+        </p:txBody>
+      </p:sp>
+      <p:sp>
+        <p:nvSpPr>
+          <p:cNvPr id="14" name="TextBox 13"/>
+          <p:cNvSpPr txBox="1"/>
+          <p:nvPr/>
+        </p:nvSpPr>
+        <p:spPr>
+          <a:xfrm>
+            <a:off x="274320" y="2660904"/>
+            <a:ext cx="457200" cy="548640"/>
+          </a:xfrm>
+          <a:prstGeom prst="rect">
+            <a:avLst/>
+          </a:prstGeom>
+          <a:noFill/>
+        </p:spPr>
+        <p:txBody>
+          <a:bodyPr wrap="square">
+            <a:spAutoFit/>
+          </a:bodyPr>
+          <a:lstStyle/>
+          <a:p>
+            <a:pPr algn="ctr"/>
+            <a:r>
+              <a:rPr sz="2000" b="1" i="0">
+                <a:solidFill>
+                  <a:srgbClr val="FFFFFF"/>
+                </a:solidFill>
+              </a:rPr>
+              <a:t>2</a:t>
+            </a:r>
+          </a:p>
+        </p:txBody>
+      </p:sp>
+      <p:sp>
+        <p:nvSpPr>
+          <p:cNvPr id="15" name="Rectangle 14"/>
+          <p:cNvSpPr/>
+          <p:nvPr/>
+        </p:nvSpPr>
+        <p:spPr>
+          <a:xfrm>
+            <a:off x="822960" y="2496312"/>
+            <a:ext cx="11091672" cy="868680"/>
+          </a:xfrm>
+          <a:prstGeom prst="rect">
+            <a:avLst/>
+          </a:prstGeom>
+          <a:solidFill>
+            <a:srgbClr val="FFFFFF"/>
+          </a:solidFill>
+          <a:ln w="12700">
+            <a:solidFill>
+              <a:srgbClr val="D6E4F5"/>
+            </a:solidFill>
+          </a:ln>
+        </p:spPr>
+        <p:style>
+          <a:lnRef idx="1">
+            <a:schemeClr val="accent1"/>
+          </a:lnRef>
+          <a:fillRef idx="3">
+            <a:schemeClr val="accent1"/>
+          </a:fillRef>
+          <a:effectRef idx="2">
+            <a:schemeClr val="accent1"/>
+          </a:effectRef>
+          <a:fontRef idx="minor">
+            <a:schemeClr val="lt1"/>
+          </a:fontRef>
+        </p:style>
+        <p:txBody>
+          <a:bodyPr rtlCol="0" anchor="ctr"/>
+          <a:lstStyle/>
+          <a:p>
+            <a:pPr algn="ctr"/>
+          </a:p>
+        </p:txBody>
+      </p:sp>
+      <p:sp>
+        <p:nvSpPr>
+          <p:cNvPr id="16" name="TextBox 15"/>
+          <p:cNvSpPr txBox="1"/>
+          <p:nvPr/>
+        </p:nvSpPr>
+        <p:spPr>
+          <a:xfrm>
+            <a:off x="960120" y="2551176"/>
+            <a:ext cx="10789920" cy="320040"/>
+          </a:xfrm>
+          <a:prstGeom prst="rect">
+            <a:avLst/>
+          </a:prstGeom>
+          <a:noFill/>
+        </p:spPr>
+        <p:txBody>
+          <a:bodyPr wrap="square">
+            <a:spAutoFit/>
+          </a:bodyPr>
+          <a:lstStyle/>
+          <a:p>
+            <a:pPr algn="l"/>
+            <a:r>
+              <a:rPr sz="1200" b="1" i="0">
+                <a:solidFill>
+                  <a:srgbClr val="002D62"/>
+                </a:solidFill>
+              </a:rPr>
+              <a:t>Métricas de calidad superiores</a:t>
+            </a:r>
+          </a:p>
+        </p:txBody>
+      </p:sp>
+      <p:sp>
+        <p:nvSpPr>
+          <p:cNvPr id="17" name="TextBox 16"/>
+          <p:cNvSpPr txBox="1"/>
+          <p:nvPr/>
+        </p:nvSpPr>
+        <p:spPr>
+          <a:xfrm>
+            <a:off x="960120" y="2862072"/>
+            <a:ext cx="10789920" cy="438912"/>
+          </a:xfrm>
+          <a:prstGeom prst="rect">
+            <a:avLst/>
+          </a:prstGeom>
+          <a:noFill/>
+        </p:spPr>
+        <p:txBody>
+          <a:bodyPr wrap="square">
+            <a:spAutoFit/>
+          </a:bodyPr>
+          <a:lstStyle/>
+          <a:p>
+            <a:pPr algn="l"/>
+            <a:r>
+              <a:rPr sz="1100" b="0" i="0">
+                <a:solidFill>
+                  <a:srgbClr val="1A1A1A"/>
+                </a:solidFill>
+              </a:rPr>
+              <a:t>AUC-ROC = 0.8998 (req. ≥ 0.85), Precisión = 99.54%, Recall = 99.40%, F1 = 0.9947. El modelo detecta anomalías con alta confianza sobre 14 features de capa de red.</a:t>
+            </a:r>
+          </a:p>
+        </p:txBody>
+      </p:sp>
+      <p:sp>
+        <p:nvSpPr>
+          <p:cNvPr id="18" name="Rectangle 17"/>
+          <p:cNvSpPr/>
+          <p:nvPr/>
+        </p:nvSpPr>
+        <p:spPr>
+          <a:xfrm>
+            <a:off x="274320" y="3483864"/>
+            <a:ext cx="457200" cy="868680"/>
+          </a:xfrm>
+          <a:prstGeom prst="rect">
+            <a:avLst/>
+          </a:prstGeom>
+          <a:solidFill>
+            <a:srgbClr val="1A7C4A"/>
+          </a:solidFill>
+          <a:ln>
+            <a:noFill/>
+          </a:ln>
+        </p:spPr>
+        <p:style>
+          <a:lnRef idx="1">
+            <a:schemeClr val="accent1"/>
+          </a:lnRef>
+          <a:fillRef idx="3">
+            <a:schemeClr val="accent1"/>
+          </a:fillRef>
+          <a:effectRef idx="2">
+            <a:schemeClr val="accent1"/>
+          </a:effectRef>
+          <a:fontRef idx="minor">
+            <a:schemeClr val="lt1"/>
+          </a:fontRef>
+        </p:style>
+        <p:txBody>
+          <a:bodyPr rtlCol="0" anchor="ctr"/>
+          <a:lstStyle/>
+          <a:p>
+            <a:pPr algn="ctr"/>
+          </a:p>
+        </p:txBody>
+      </p:sp>
+      <p:sp>
+        <p:nvSpPr>
+          <p:cNvPr id="19" name="TextBox 18"/>
+          <p:cNvSpPr txBox="1"/>
+          <p:nvPr/>
+        </p:nvSpPr>
+        <p:spPr>
+          <a:xfrm>
+            <a:off x="274320" y="3648456"/>
+            <a:ext cx="457200" cy="548640"/>
+          </a:xfrm>
+          <a:prstGeom prst="rect">
+            <a:avLst/>
+          </a:prstGeom>
+          <a:noFill/>
+        </p:spPr>
+        <p:txBody>
+          <a:bodyPr wrap="square">
+            <a:spAutoFit/>
+          </a:bodyPr>
+          <a:lstStyle/>
+          <a:p>
+            <a:pPr algn="ctr"/>
+            <a:r>
+              <a:rPr sz="2000" b="1" i="0">
+                <a:solidFill>
+                  <a:srgbClr val="FFFFFF"/>
+                </a:solidFill>
+              </a:rPr>
+              <a:t>3</a:t>
+            </a:r>
+          </a:p>
+        </p:txBody>
+      </p:sp>
+      <p:sp>
+        <p:nvSpPr>
+          <p:cNvPr id="20" name="Rectangle 19"/>
+          <p:cNvSpPr/>
+          <p:nvPr/>
+        </p:nvSpPr>
+        <p:spPr>
+          <a:xfrm>
+            <a:off x="822960" y="3483864"/>
+            <a:ext cx="11091672" cy="868680"/>
+          </a:xfrm>
+          <a:prstGeom prst="rect">
+            <a:avLst/>
+          </a:prstGeom>
+          <a:solidFill>
+            <a:srgbClr val="FFFFFF"/>
+          </a:solidFill>
+          <a:ln w="12700">
+            <a:solidFill>
+              <a:srgbClr val="D6E4F5"/>
+            </a:solidFill>
+          </a:ln>
+        </p:spPr>
+        <p:style>
+          <a:lnRef idx="1">
+            <a:schemeClr val="accent1"/>
+          </a:lnRef>
+          <a:fillRef idx="3">
+            <a:schemeClr val="accent1"/>
+          </a:fillRef>
+          <a:effectRef idx="2">
+            <a:schemeClr val="accent1"/>
+          </a:effectRef>
+          <a:fontRef idx="minor">
+            <a:schemeClr val="lt1"/>
+          </a:fontRef>
+        </p:style>
+        <p:txBody>
+          <a:bodyPr rtlCol="0" anchor="ctr"/>
+          <a:lstStyle/>
+          <a:p>
+            <a:pPr algn="ctr"/>
+          </a:p>
+        </p:txBody>
+      </p:sp>
+      <p:sp>
+        <p:nvSpPr>
+          <p:cNvPr id="21" name="TextBox 20"/>
+          <p:cNvSpPr txBox="1"/>
+          <p:nvPr/>
+        </p:nvSpPr>
+        <p:spPr>
+          <a:xfrm>
+            <a:off x="960120" y="3538728"/>
+            <a:ext cx="10789920" cy="320040"/>
+          </a:xfrm>
+          <a:prstGeom prst="rect">
+            <a:avLst/>
+          </a:prstGeom>
+          <a:noFill/>
+        </p:spPr>
+        <p:txBody>
+          <a:bodyPr wrap="square">
+            <a:spAutoFit/>
+          </a:bodyPr>
+          <a:lstStyle/>
+          <a:p>
+            <a:pPr algn="l"/>
+            <a:r>
+              <a:rPr sz="1200" b="1" i="0">
+                <a:solidFill>
+                  <a:srgbClr val="002D62"/>
+                </a:solidFill>
+              </a:rPr>
+              <a:t>Respuesta automática en tiempo real</a:t>
+            </a:r>
+          </a:p>
+        </p:txBody>
+      </p:sp>
+      <p:sp>
+        <p:nvSpPr>
+          <p:cNvPr id="22" name="TextBox 21"/>
+          <p:cNvSpPr txBox="1"/>
+          <p:nvPr/>
+        </p:nvSpPr>
+        <p:spPr>
+          <a:xfrm>
+            <a:off x="960120" y="3849624"/>
+            <a:ext cx="10789920" cy="438912"/>
+          </a:xfrm>
+          <a:prstGeom prst="rect">
+            <a:avLst/>
+          </a:prstGeom>
+          <a:noFill/>
+        </p:spPr>
+        <p:txBody>
+          <a:bodyPr wrap="square">
+            <a:spAutoFit/>
+          </a:bodyPr>
+          <a:lstStyle/>
+          <a:p>
+            <a:pPr algn="l"/>
+            <a:r>
+              <a:rPr sz="1100" b="0" i="0">
+                <a:solidFill>
+                  <a:srgbClr val="1A1A1A"/>
+                </a:solidFill>
+              </a:rPr>
+              <a:t>Latencia P95 = 34.8ms (req. &lt;500ms, mejora de 14×). Lead Time de detección ≈ 62s limitado por el timeout de Suricata para flows TCP half-open.</a:t>
+            </a:r>
+          </a:p>
+        </p:txBody>
+      </p:sp>
+      <p:sp>
+        <p:nvSpPr>
+          <p:cNvPr id="23" name="Rectangle 22"/>
+          <p:cNvSpPr/>
+          <p:nvPr/>
+        </p:nvSpPr>
+        <p:spPr>
+          <a:xfrm>
+            <a:off x="274320" y="4471416"/>
+            <a:ext cx="457200" cy="868680"/>
+          </a:xfrm>
+          <a:prstGeom prst="rect">
+            <a:avLst/>
+          </a:prstGeom>
+          <a:solidFill>
+            <a:srgbClr val="1A7C4A"/>
+          </a:solidFill>
+          <a:ln>
+            <a:noFill/>
+          </a:ln>
+        </p:spPr>
+        <p:style>
+          <a:lnRef idx="1">
+            <a:schemeClr val="accent1"/>
+          </a:lnRef>
+          <a:fillRef idx="3">
+            <a:schemeClr val="accent1"/>
+          </a:fillRef>
+          <a:effectRef idx="2">
+            <a:schemeClr val="accent1"/>
+          </a:effectRef>
+          <a:fontRef idx="minor">
+            <a:schemeClr val="lt1"/>
+          </a:fontRef>
+        </p:style>
+        <p:txBody>
+          <a:bodyPr rtlCol="0" anchor="ctr"/>
+          <a:lstStyle/>
+          <a:p>
+            <a:pPr algn="ctr"/>
+          </a:p>
+        </p:txBody>
+      </p:sp>
+      <p:sp>
+        <p:nvSpPr>
+          <p:cNvPr id="24" name="TextBox 23"/>
+          <p:cNvSpPr txBox="1"/>
+          <p:nvPr/>
+        </p:nvSpPr>
+        <p:spPr>
+          <a:xfrm>
+            <a:off x="274320" y="4636008"/>
+            <a:ext cx="457200" cy="548640"/>
+          </a:xfrm>
+          <a:prstGeom prst="rect">
+            <a:avLst/>
+          </a:prstGeom>
+          <a:noFill/>
+        </p:spPr>
+        <p:txBody>
+          <a:bodyPr wrap="square">
+            <a:spAutoFit/>
+          </a:bodyPr>
+          <a:lstStyle/>
+          <a:p>
+            <a:pPr algn="ctr"/>
+            <a:r>
+              <a:rPr sz="2000" b="1" i="0">
+                <a:solidFill>
+                  <a:srgbClr val="FFFFFF"/>
+                </a:solidFill>
+              </a:rPr>
+              <a:t>4</a:t>
+            </a:r>
+          </a:p>
+        </p:txBody>
+      </p:sp>
+      <p:sp>
+        <p:nvSpPr>
+          <p:cNvPr id="25" name="Rectangle 24"/>
+          <p:cNvSpPr/>
+          <p:nvPr/>
+        </p:nvSpPr>
+        <p:spPr>
+          <a:xfrm>
+            <a:off x="822960" y="4471416"/>
+            <a:ext cx="11091672" cy="868680"/>
+          </a:xfrm>
+          <a:prstGeom prst="rect">
+            <a:avLst/>
+          </a:prstGeom>
+          <a:solidFill>
+            <a:srgbClr val="FFFFFF"/>
+          </a:solidFill>
+          <a:ln w="12700">
+            <a:solidFill>
+              <a:srgbClr val="D6E4F5"/>
+            </a:solidFill>
+          </a:ln>
+        </p:spPr>
+        <p:style>
+          <a:lnRef idx="1">
+            <a:schemeClr val="accent1"/>
+          </a:lnRef>
+          <a:fillRef idx="3">
+            <a:schemeClr val="accent1"/>
+          </a:fillRef>
+          <a:effectRef idx="2">
+            <a:schemeClr val="accent1"/>
+          </a:effectRef>
+          <a:fontRef idx="minor">
+            <a:schemeClr val="lt1"/>
+          </a:fontRef>
+        </p:style>
+        <p:txBody>
+          <a:bodyPr rtlCol="0" anchor="ctr"/>
+          <a:lstStyle/>
+          <a:p>
+            <a:pPr algn="ctr"/>
+          </a:p>
+        </p:txBody>
+      </p:sp>
+      <p:sp>
+        <p:nvSpPr>
+          <p:cNvPr id="26" name="TextBox 25"/>
+          <p:cNvSpPr txBox="1"/>
+          <p:nvPr/>
+        </p:nvSpPr>
+        <p:spPr>
+          <a:xfrm>
+            <a:off x="960120" y="4526280"/>
+            <a:ext cx="10789920" cy="320040"/>
+          </a:xfrm>
+          <a:prstGeom prst="rect">
+            <a:avLst/>
+          </a:prstGeom>
+          <a:noFill/>
+        </p:spPr>
+        <p:txBody>
+          <a:bodyPr wrap="square">
+            <a:spAutoFit/>
+          </a:bodyPr>
+          <a:lstStyle/>
+          <a:p>
+            <a:pPr algn="l"/>
+            <a:r>
+              <a:rPr sz="1200" b="1" i="0">
+                <a:solidFill>
+                  <a:srgbClr val="002D62"/>
+                </a:solidFill>
+              </a:rPr>
+              <a:t>Disponibilidad garantizada</a:t>
+            </a:r>
+          </a:p>
+        </p:txBody>
+      </p:sp>
+      <p:sp>
+        <p:nvSpPr>
+          <p:cNvPr id="27" name="TextBox 26"/>
+          <p:cNvSpPr txBox="1"/>
+          <p:nvPr/>
+        </p:nvSpPr>
+        <p:spPr>
+          <a:xfrm>
+            <a:off x="960120" y="4837176"/>
+            <a:ext cx="10789920" cy="438912"/>
+          </a:xfrm>
+          <a:prstGeom prst="rect">
+            <a:avLst/>
+          </a:prstGeom>
+          <a:noFill/>
+        </p:spPr>
+        <p:txBody>
+          <a:bodyPr wrap="square">
+            <a:spAutoFit/>
+          </a:bodyPr>
+          <a:lstStyle/>
+          <a:p>
+            <a:pPr algn="l"/>
+            <a:r>
+              <a:rPr sz="1100" b="0" i="0">
+                <a:solidFill>
+                  <a:srgbClr val="1A1A1A"/>
+                </a:solidFill>
+              </a:rPr>
+              <a:t>40/40 corridas con Disponibilidad = 100% e ITL = 0%. El mecanismo de whitelist previene auto-bloqueo del sistema.</a:t>
+            </a:r>
+          </a:p>
+        </p:txBody>
+      </p:sp>
+      <p:sp>
+        <p:nvSpPr>
+          <p:cNvPr id="28" name="Rectangle 27"/>
+          <p:cNvSpPr/>
+          <p:nvPr/>
+        </p:nvSpPr>
+        <p:spPr>
+          <a:xfrm>
+            <a:off x="274320" y="5458968"/>
+            <a:ext cx="457200" cy="868680"/>
+          </a:xfrm>
+          <a:prstGeom prst="rect">
+            <a:avLst/>
+          </a:prstGeom>
+          <a:solidFill>
+            <a:srgbClr val="1A7C4A"/>
+          </a:solidFill>
+          <a:ln>
+            <a:noFill/>
+          </a:ln>
+        </p:spPr>
+        <p:style>
+          <a:lnRef idx="1">
+            <a:schemeClr val="accent1"/>
+          </a:lnRef>
+          <a:fillRef idx="3">
+            <a:schemeClr val="accent1"/>
+          </a:fillRef>
+          <a:effectRef idx="2">
+            <a:schemeClr val="accent1"/>
+          </a:effectRef>
+          <a:fontRef idx="minor">
+            <a:schemeClr val="lt1"/>
+          </a:fontRef>
+        </p:style>
+        <p:txBody>
+          <a:bodyPr rtlCol="0" anchor="ctr"/>
+          <a:lstStyle/>
+          <a:p>
+            <a:pPr algn="ctr"/>
+          </a:p>
+        </p:txBody>
+      </p:sp>
+      <p:sp>
+        <p:nvSpPr>
+          <p:cNvPr id="29" name="TextBox 28"/>
+          <p:cNvSpPr txBox="1"/>
+          <p:nvPr/>
+        </p:nvSpPr>
+        <p:spPr>
+          <a:xfrm>
+            <a:off x="274320" y="5623560"/>
+            <a:ext cx="457200" cy="548640"/>
+          </a:xfrm>
+          <a:prstGeom prst="rect">
+            <a:avLst/>
+          </a:prstGeom>
+          <a:noFill/>
+        </p:spPr>
+        <p:txBody>
+          <a:bodyPr wrap="square">
+            <a:spAutoFit/>
+          </a:bodyPr>
+          <a:lstStyle/>
+          <a:p>
+            <a:pPr algn="ctr"/>
+            <a:r>
+              <a:rPr sz="2000" b="1" i="0">
+                <a:solidFill>
+                  <a:srgbClr val="FFFFFF"/>
+                </a:solidFill>
+              </a:rPr>
+              <a:t>5</a:t>
+            </a:r>
+          </a:p>
+        </p:txBody>
+      </p:sp>
+      <p:sp>
+        <p:nvSpPr>
+          <p:cNvPr id="30" name="Rectangle 29"/>
+          <p:cNvSpPr/>
+          <p:nvPr/>
+        </p:nvSpPr>
+        <p:spPr>
+          <a:xfrm>
+            <a:off x="822960" y="5458968"/>
+            <a:ext cx="11091672" cy="868680"/>
+          </a:xfrm>
+          <a:prstGeom prst="rect">
+            <a:avLst/>
+          </a:prstGeom>
+          <a:solidFill>
+            <a:srgbClr val="FFFFFF"/>
+          </a:solidFill>
+          <a:ln w="12700">
+            <a:solidFill>
+              <a:srgbClr val="D6E4F5"/>
+            </a:solidFill>
+          </a:ln>
+        </p:spPr>
+        <p:style>
+          <a:lnRef idx="1">
+            <a:schemeClr val="accent1"/>
+          </a:lnRef>
+          <a:fillRef idx="3">
+            <a:schemeClr val="accent1"/>
+          </a:fillRef>
+          <a:effectRef idx="2">
+            <a:schemeClr val="accent1"/>
+          </a:effectRef>
+          <a:fontRef idx="minor">
+            <a:schemeClr val="lt1"/>
+          </a:fontRef>
+        </p:style>
+        <p:txBody>
+          <a:bodyPr rtlCol="0" anchor="ctr"/>
+          <a:lstStyle/>
+          <a:p>
+            <a:pPr algn="ctr"/>
+          </a:p>
+        </p:txBody>
+      </p:sp>
+      <p:sp>
+        <p:nvSpPr>
+          <p:cNvPr id="31" name="TextBox 30"/>
+          <p:cNvSpPr txBox="1"/>
+          <p:nvPr/>
+        </p:nvSpPr>
+        <p:spPr>
+          <a:xfrm>
+            <a:off x="960120" y="5513832"/>
+            <a:ext cx="10789920" cy="320040"/>
+          </a:xfrm>
+          <a:prstGeom prst="rect">
+            <a:avLst/>
+          </a:prstGeom>
+          <a:noFill/>
+        </p:spPr>
+        <p:txBody>
+          <a:bodyPr wrap="square">
+            <a:spAutoFit/>
+          </a:bodyPr>
+          <a:lstStyle/>
+          <a:p>
+            <a:pPr algn="l"/>
+            <a:r>
+              <a:rPr sz="1200" b="1" i="0">
+                <a:solidFill>
+                  <a:srgbClr val="002D62"/>
+                </a:solidFill>
+              </a:rPr>
+              <a:t>Defensa justificada del umbral FPR=20.47%</a:t>
+            </a:r>
+          </a:p>
+        </p:txBody>
+      </p:sp>
+      <p:sp>
+        <p:nvSpPr>
+          <p:cNvPr id="32" name="TextBox 31"/>
+          <p:cNvSpPr txBox="1"/>
+          <p:nvPr/>
+        </p:nvSpPr>
+        <p:spPr>
+          <a:xfrm>
+            <a:off x="960120" y="5824728"/>
+            <a:ext cx="10789920" cy="438912"/>
+          </a:xfrm>
+          <a:prstGeom prst="rect">
+            <a:avLst/>
+          </a:prstGeom>
+          <a:noFill/>
+        </p:spPr>
+        <p:txBody>
+          <a:bodyPr wrap="square">
+            <a:spAutoFit/>
+          </a:bodyPr>
+          <a:lstStyle/>
+          <a:p>
+            <a:pPr algn="l"/>
+            <a:r>
+              <a:rPr sz="1100" b="0" i="0">
+                <a:solidFill>
+                  <a:srgbClr val="1A1A1A"/>
+                </a:solidFill>
+              </a:rPr>
+              <a:t>Reducir FPR a ≤5% sacrificaría la detección de SYN Flood (score≈−0.49 &gt; τ1=−0.555). El índice de Youden es el umbral metodológicamente correcto en este contexto.</a:t>
+            </a:r>
+          </a:p>
+        </p:txBody>
+      </p:sp>
+    </p:spTree>
+  </p:cSld>
+  <p:clrMapOvr>
+    <a:masterClrMapping/>
+  </p:clrMapOvr>
+</p:sld>
+</file>
+
+<file path=ppt/slides/slide17.xml><?xml version="1.0" encoding="utf-8"?>
+<p:sld xmlns:a="http://schemas.openxmlformats.org/drawingml/2006/main" xmlns:p="http://schemas.openxmlformats.org/presentationml/2006/main" xmlns:r="http://schemas.openxmlformats.org/officeDocument/2006/relationships">
+  <p:cSld>
+    <p:spTree>
+      <p:nvGrpSpPr>
+        <p:cNvPr id="1" name=""/>
+        <p:cNvGrpSpPr/>
+        <p:nvPr/>
+      </p:nvGrpSpPr>
+      <p:grpSpPr/>
+      <p:sp>
+        <p:nvSpPr>
+          <p:cNvPr id="2" name="Rectangle 1"/>
+          <p:cNvSpPr/>
+          <p:nvPr/>
+        </p:nvSpPr>
+        <p:spPr>
+          <a:xfrm>
+            <a:off x="0" y="0"/>
+            <a:ext cx="12188952" cy="6858000"/>
+          </a:xfrm>
+          <a:prstGeom prst="rect">
+            <a:avLst/>
+          </a:prstGeom>
+          <a:solidFill>
+            <a:srgbClr val="F2F4F8"/>
+          </a:solidFill>
+          <a:ln>
+            <a:noFill/>
+          </a:ln>
+        </p:spPr>
+        <p:style>
+          <a:lnRef idx="1">
+            <a:schemeClr val="accent1"/>
+          </a:lnRef>
+          <a:fillRef idx="3">
+            <a:schemeClr val="accent1"/>
+          </a:fillRef>
+          <a:effectRef idx="2">
+            <a:schemeClr val="accent1"/>
+          </a:effectRef>
+          <a:fontRef idx="minor">
+            <a:schemeClr val="lt1"/>
+          </a:fontRef>
+        </p:style>
+        <p:txBody>
+          <a:bodyPr rtlCol="0" anchor="ctr"/>
+          <a:lstStyle/>
+          <a:p>
+            <a:pPr algn="ctr"/>
+          </a:p>
+        </p:txBody>
+      </p:sp>
+      <p:sp>
+        <p:nvSpPr>
+          <p:cNvPr id="3" name="Rectangle 2"/>
+          <p:cNvSpPr/>
+          <p:nvPr/>
+        </p:nvSpPr>
+        <p:spPr>
+          <a:xfrm>
+            <a:off x="0" y="0"/>
+            <a:ext cx="12188952" cy="1280160"/>
+          </a:xfrm>
+          <a:prstGeom prst="rect">
+            <a:avLst/>
+          </a:prstGeom>
+          <a:solidFill>
+            <a:srgbClr val="002D62"/>
+          </a:solidFill>
+          <a:ln>
+            <a:noFill/>
+          </a:ln>
+        </p:spPr>
+        <p:style>
+          <a:lnRef idx="1">
+            <a:schemeClr val="accent1"/>
+          </a:lnRef>
+          <a:fillRef idx="3">
+            <a:schemeClr val="accent1"/>
+          </a:fillRef>
+          <a:effectRef idx="2">
+            <a:schemeClr val="accent1"/>
+          </a:effectRef>
+          <a:fontRef idx="minor">
+            <a:schemeClr val="lt1"/>
+          </a:fontRef>
+        </p:style>
+        <p:txBody>
+          <a:bodyPr rtlCol="0" anchor="ctr"/>
+          <a:lstStyle/>
+          <a:p>
+            <a:pPr algn="ctr"/>
+          </a:p>
+        </p:txBody>
+      </p:sp>
+      <p:sp>
+        <p:nvSpPr>
+          <p:cNvPr id="4" name="TextBox 3"/>
+          <p:cNvSpPr txBox="1"/>
+          <p:nvPr/>
+        </p:nvSpPr>
+        <p:spPr>
+          <a:xfrm>
+            <a:off x="320040" y="137160"/>
+            <a:ext cx="11430000" cy="685800"/>
+          </a:xfrm>
+          <a:prstGeom prst="rect">
+            <a:avLst/>
+          </a:prstGeom>
+          <a:noFill/>
+        </p:spPr>
+        <p:txBody>
+          <a:bodyPr wrap="square">
+            <a:spAutoFit/>
+          </a:bodyPr>
+          <a:lstStyle/>
+          <a:p>
+            <a:pPr algn="l"/>
+            <a:r>
+              <a:rPr sz="2800" b="1" i="0">
+                <a:solidFill>
+                  <a:srgbClr val="FFFFFF"/>
+                </a:solidFill>
+              </a:rPr>
+              <a:t>Trabajo Futuro  /  Preguntas</a:t>
+            </a:r>
+          </a:p>
+        </p:txBody>
+      </p:sp>
+      <p:sp>
+        <p:nvSpPr>
+          <p:cNvPr id="5" name="TextBox 4"/>
+          <p:cNvSpPr txBox="1"/>
+          <p:nvPr/>
+        </p:nvSpPr>
+        <p:spPr>
+          <a:xfrm>
+            <a:off x="320040" y="777240"/>
+            <a:ext cx="11430000" cy="411480"/>
+          </a:xfrm>
+          <a:prstGeom prst="rect">
+            <a:avLst/>
+          </a:prstGeom>
+          <a:noFill/>
+        </p:spPr>
+        <p:txBody>
+          <a:bodyPr wrap="square">
+            <a:spAutoFit/>
+          </a:bodyPr>
+          <a:lstStyle/>
+          <a:p>
+            <a:pPr algn="l"/>
+            <a:r>
+              <a:rPr sz="1400" b="0" i="0">
+                <a:solidFill>
+                  <a:srgbClr val="D6E4F5"/>
+                </a:solidFill>
+              </a:rPr>
+              <a:t>Líneas de extensión del sistema</a:t>
+            </a:r>
+          </a:p>
+        </p:txBody>
+      </p:sp>
+      <p:sp>
+        <p:nvSpPr>
+          <p:cNvPr id="6" name="Rectangle 5"/>
+          <p:cNvSpPr/>
+          <p:nvPr/>
+        </p:nvSpPr>
+        <p:spPr>
+          <a:xfrm>
+            <a:off x="0" y="6601968"/>
+            <a:ext cx="12188952" cy="256032"/>
+          </a:xfrm>
+          <a:prstGeom prst="rect">
+            <a:avLst/>
+          </a:prstGeom>
+          <a:solidFill>
+            <a:srgbClr val="004A99"/>
+          </a:solidFill>
+          <a:ln>
+            <a:noFill/>
+          </a:ln>
+        </p:spPr>
+        <p:style>
+          <a:lnRef idx="1">
+            <a:schemeClr val="accent1"/>
+          </a:lnRef>
+          <a:fillRef idx="3">
+            <a:schemeClr val="accent1"/>
+          </a:fillRef>
+          <a:effectRef idx="2">
+            <a:schemeClr val="accent1"/>
+          </a:effectRef>
+          <a:fontRef idx="minor">
+            <a:schemeClr val="lt1"/>
+          </a:fontRef>
+        </p:style>
+        <p:txBody>
+          <a:bodyPr rtlCol="0" anchor="ctr"/>
+          <a:lstStyle/>
+          <a:p>
+            <a:pPr algn="ctr"/>
+          </a:p>
+        </p:txBody>
+      </p:sp>
+      <p:sp>
+        <p:nvSpPr>
+          <p:cNvPr id="7" name="TextBox 6"/>
+          <p:cNvSpPr txBox="1"/>
+          <p:nvPr/>
+        </p:nvSpPr>
+        <p:spPr>
+          <a:xfrm>
+            <a:off x="274320" y="6601968"/>
+            <a:ext cx="11430000" cy="256032"/>
+          </a:xfrm>
+          <a:prstGeom prst="rect">
+            <a:avLst/>
+          </a:prstGeom>
+          <a:noFill/>
+        </p:spPr>
+        <p:txBody>
+          <a:bodyPr wrap="square">
+            <a:spAutoFit/>
+          </a:bodyPr>
+          <a:lstStyle/>
+          <a:p>
+            <a:pPr algn="ctr"/>
+            <a:r>
+              <a:rPr sz="900" b="0" i="0">
+                <a:solidFill>
+                  <a:srgbClr val="FFFFFF"/>
+                </a:solidFill>
+              </a:rPr>
+              <a:t>PPI — UPeU 2026  |  Rubén Salazar Tocas  |  17/17</a:t>
+            </a:r>
+          </a:p>
+        </p:txBody>
+      </p:sp>
+      <p:sp>
+        <p:nvSpPr>
+          <p:cNvPr id="8" name="Rectangle 7"/>
+          <p:cNvSpPr/>
+          <p:nvPr/>
+        </p:nvSpPr>
+        <p:spPr>
+          <a:xfrm>
+            <a:off x="274320" y="1463040"/>
+            <a:ext cx="5760720" cy="5120640"/>
+          </a:xfrm>
+          <a:prstGeom prst="rect">
+            <a:avLst/>
+          </a:prstGeom>
+          <a:solidFill>
+            <a:srgbClr val="FFFFFF"/>
+          </a:solidFill>
+          <a:ln w="12700">
+            <a:solidFill>
+              <a:srgbClr val="D6E4F5"/>
+            </a:solidFill>
+          </a:ln>
+        </p:spPr>
+        <p:style>
+          <a:lnRef idx="1">
+            <a:schemeClr val="accent1"/>
+          </a:lnRef>
+          <a:fillRef idx="3">
+            <a:schemeClr val="accent1"/>
+          </a:fillRef>
+          <a:effectRef idx="2">
+            <a:schemeClr val="accent1"/>
+          </a:effectRef>
+          <a:fontRef idx="minor">
+            <a:schemeClr val="lt1"/>
+          </a:fontRef>
+        </p:style>
+        <p:txBody>
+          <a:bodyPr rtlCol="0" anchor="ctr"/>
+          <a:lstStyle/>
+          <a:p>
+            <a:pPr algn="ctr"/>
+          </a:p>
+        </p:txBody>
+      </p:sp>
+      <p:sp>
+        <p:nvSpPr>
           <p:cNvPr id="9" name="TextBox 8"/>
           <p:cNvSpPr txBox="1"/>
           <p:nvPr/>
@@ -17609,7 +20628,7 @@
                   <a:srgbClr val="1A1A1A"/>
                 </a:solidFill>
               </a:rPr>
-              <a:t>• Extender whitelist dinámica (DHCP/LDAP)</a:t>
+              <a:t>• Ensemble IF + AE (AND gate): FPR -49%, F1 +4.8pp</a:t>
             </a:r>
           </a:p>
         </p:txBody>
@@ -17677,7 +20696,7 @@
                   <a:srgbClr val="1A1A1A"/>
                 </a:solidFill>
               </a:rPr>
-              <a:t>• Soporte multi-sensor (agente distribuido)</a:t>
+              <a:t>• Extender whitelist dinámica (DHCP/LDAP)</a:t>
             </a:r>
           </a:p>
         </p:txBody>
@@ -17711,7 +20730,7 @@
                   <a:srgbClr val="1A1A1A"/>
                 </a:solidFill>
               </a:rPr>
-              <a:t>• Integración con SIEM (Wazuh / Elastic)</a:t>
+              <a:t>• Soporte multi-sensor (agente distribuido)</a:t>
             </a:r>
           </a:p>
         </p:txBody>
@@ -17745,7 +20764,7 @@
                   <a:srgbClr val="1A1A1A"/>
                 </a:solidFill>
               </a:rPr>
-              <a:t>• Modelo híbrido: IF + Autoencoder LSTM</a:t>
+              <a:t>• Integración con SIEM (Wazuh / Elastic)</a:t>
             </a:r>
           </a:p>
         </p:txBody>
@@ -17813,7 +20832,7 @@
                   <a:srgbClr val="1A1A1A"/>
                 </a:solidFill>
               </a:rPr>
-              <a:t>• Reducción FPR via ensemble de modelos</a:t>
+              <a:t>• Predictor con ventana de series temporales (LSTM)</a:t>
             </a:r>
           </a:p>
         </p:txBody>
@@ -18411,7 +21430,7 @@
                   <a:srgbClr val="FFFFFF"/>
                 </a:solidFill>
               </a:rPr>
-              <a:t>PPI — UPeU 2026  |  Rubén Salazar Tocas  |  2/16</a:t>
+              <a:t>PPI — UPeU 2026  |  Rubén Salazar Tocas  |  2/17</a:t>
             </a:r>
           </a:p>
         </p:txBody>
@@ -18853,7 +21872,7 @@
                   <a:srgbClr val="1A1A1A"/>
                 </a:solidFill>
               </a:rPr>
-              <a:t>• 13. Conclusiones</a:t>
+              <a:t>• 13. Módulo Predictor — XGBoost</a:t>
             </a:r>
           </a:p>
         </p:txBody>
@@ -18887,7 +21906,7 @@
                   <a:srgbClr val="1A1A1A"/>
                 </a:solidFill>
               </a:rPr>
-              <a:t>• 14. Trabajo futuro</a:t>
+              <a:t>• 14. Conclusiones</a:t>
             </a:r>
           </a:p>
         </p:txBody>
@@ -18921,14 +21940,48 @@
                   <a:srgbClr val="1A1A1A"/>
                 </a:solidFill>
               </a:rPr>
-              <a:t>• 15. Preguntas</a:t>
-            </a:r>
-          </a:p>
-        </p:txBody>
-      </p:sp>
-      <p:sp>
-        <p:nvSpPr>
-          <p:cNvPr id="23" name="Rectangle 22"/>
+              <a:t>• 15. Trabajo futuro</a:t>
+            </a:r>
+          </a:p>
+        </p:txBody>
+      </p:sp>
+      <p:sp>
+        <p:nvSpPr>
+          <p:cNvPr id="23" name="TextBox 22"/>
+          <p:cNvSpPr txBox="1"/>
+          <p:nvPr/>
+        </p:nvSpPr>
+        <p:spPr>
+          <a:xfrm>
+            <a:off x="6309360" y="3831336"/>
+            <a:ext cx="5486400" cy="384048"/>
+          </a:xfrm>
+          <a:prstGeom prst="rect">
+            <a:avLst/>
+          </a:prstGeom>
+          <a:noFill/>
+        </p:spPr>
+        <p:txBody>
+          <a:bodyPr wrap="square">
+            <a:spAutoFit/>
+          </a:bodyPr>
+          <a:lstStyle/>
+          <a:p>
+            <a:pPr algn="l"/>
+            <a:r>
+              <a:rPr sz="1500" b="0" i="0">
+                <a:solidFill>
+                  <a:srgbClr val="1A1A1A"/>
+                </a:solidFill>
+              </a:rPr>
+              <a:t>• 16. Preguntas</a:t>
+            </a:r>
+          </a:p>
+        </p:txBody>
+      </p:sp>
+      <p:sp>
+        <p:nvSpPr>
+          <p:cNvPr id="24" name="Rectangle 23"/>
           <p:cNvSpPr/>
           <p:nvPr/>
         </p:nvSpPr>
@@ -19213,7 +22266,7 @@
                   <a:srgbClr val="FFFFFF"/>
                 </a:solidFill>
               </a:rPr>
-              <a:t>PPI — UPeU 2026  |  Rubén Salazar Tocas  |  3/16</a:t>
+              <a:t>PPI — UPeU 2026  |  Rubén Salazar Tocas  |  3/17</a:t>
             </a:r>
           </a:p>
         </p:txBody>
@@ -20437,7 +23490,7 @@
                   <a:srgbClr val="FFFFFF"/>
                 </a:solidFill>
               </a:rPr>
-              <a:t>PPI — UPeU 2026  |  Rubén Salazar Tocas  |  4/16</a:t>
+              <a:t>PPI — UPeU 2026  |  Rubén Salazar Tocas  |  4/17</a:t>
             </a:r>
           </a:p>
         </p:txBody>
@@ -21318,7 +24371,7 @@
                   <a:srgbClr val="FFFFFF"/>
                 </a:solidFill>
               </a:rPr>
-              <a:t>PPI — UPeU 2026  |  Rubén Salazar Tocas  |  5/16</a:t>
+              <a:t>PPI — UPeU 2026  |  Rubén Salazar Tocas  |  5/17</a:t>
             </a:r>
           </a:p>
         </p:txBody>
@@ -22019,7 +25072,7 @@
                   <a:srgbClr val="FFFFFF"/>
                 </a:solidFill>
               </a:rPr>
-              <a:t>PPI — UPeU 2026  |  Rubén Salazar Tocas  |  6/16</a:t>
+              <a:t>PPI — UPeU 2026  |  Rubén Salazar Tocas  |  6/17</a:t>
             </a:r>
           </a:p>
         </p:txBody>
@@ -24416,7 +27469,7 @@
                   <a:srgbClr val="FFFFFF"/>
                 </a:solidFill>
               </a:rPr>
-              <a:t>PPI — UPeU 2026  |  Rubén Salazar Tocas  |  7/16</a:t>
+              <a:t>PPI — UPeU 2026  |  Rubén Salazar Tocas  |  7/17</a:t>
             </a:r>
           </a:p>
         </p:txBody>
@@ -24707,7 +27760,7 @@
                   <a:srgbClr val="FFFFFF"/>
                 </a:solidFill>
               </a:rPr>
-              <a:t>Preproceso</a:t>
+              <a:t>Captura</a:t>
             </a:r>
           </a:p>
         </p:txBody>
@@ -24741,8 +27794,8 @@
                   <a:srgbClr val="D6E4F5"/>
                 </a:solidFill>
               </a:rPr>
-              <a:t>parser.py
-14 features</a:t>
+              <a:t>3 grupos
+.gz directo</a:t>
             </a:r>
           </a:p>
         </p:txBody>
@@ -25541,7 +28594,7 @@
                   <a:srgbClr val="1A1A1A"/>
                 </a:solidFill>
               </a:rPr>
-              <a:t>[F1–F2]  Suricata captura flows en eve.json. parser.py extrae 14 features. etiquetar_limpiar.py deduplica y particiona en train/val/test (70/15/15 cronológico).</a:t>
+              <a:t>[F1–F2]  Suricata captura flows en eve.json. Captura separada: Grupo A=normal puro (Kali apagada), B=ataques puros (Desktop quieto), C=mixto (motor detenido). Los .gz son la fuente directa para F3 — sin CSVs intermedios.</a:t>
             </a:r>
           </a:p>
         </p:txBody>
@@ -25575,7 +28628,7 @@
                   <a:srgbClr val="1A1A1A"/>
                 </a:solidFill>
               </a:rPr>
-              <a:t>[F3]  Isolation Forest (n=300, contamination=0.05) entrenado solo con flujos normales. auc_roc_umbrales.py deriva τ1/τ2 desde la curva ROC.</a:t>
+              <a:t>[F3]  Isolation Forest (n=300, contamination=0.05) entrenado solo con flujos normales. fase3_evaluar.py evalúa holdout 20% + Grupo B → ROC → τ1/τ2 → metricas_offline.txt (fuente única).</a:t>
             </a:r>
           </a:p>
         </p:txBody>
@@ -25892,7 +28945,7 @@
                   <a:srgbClr val="FFFFFF"/>
                 </a:solidFill>
               </a:rPr>
-              <a:t>PPI — UPeU 2026  |  Rubén Salazar Tocas  |  8/16</a:t>
+              <a:t>PPI — UPeU 2026  |  Rubén Salazar Tocas  |  8/17</a:t>
             </a:r>
           </a:p>
         </p:txBody>
@@ -26843,7 +29896,7 @@
                   <a:srgbClr val="F5A623"/>
                 </a:solidFill>
               </a:rPr>
-              <a:t>70/15/15</a:t>
+              <a:t>80/20</a:t>
             </a:r>
           </a:p>
         </p:txBody>
@@ -26877,7 +29930,7 @@
                   <a:srgbClr val="FFFFFF"/>
                 </a:solidFill>
               </a:rPr>
-              <a:t>Split train/val/test (cronológico)</a:t>
+              <a:t>Split entrenamiento/holdout (aleatorio, seed=42)</a:t>
             </a:r>
           </a:p>
         </p:txBody>
@@ -27194,7 +30247,7 @@
                   <a:srgbClr val="FFFFFF"/>
                 </a:solidFill>
               </a:rPr>
-              <a:t>PPI — UPeU 2026  |  Rubén Salazar Tocas  |  9/16</a:t>
+              <a:t>PPI — UPeU 2026  |  Rubén Salazar Tocas  |  9/17</a:t>
             </a:r>
           </a:p>
         </p:txBody>

</xml_diff>